<commit_message>
Split overflowing slides into tighter pages (17 -> 24 slides)
Each slide now caps at ~5 bullets with short lines. Long phases (4, 5, 6,
7) split across two slides each. Big Picture split into in-class /
homework. Review Discipline split into 'catch now' / 'don't bother'.
Pandoc default template doesn't auto-shrink content; tighter source
markdown is the reliable fix.

Co-Authored-By: Claude Opus 4.7 (1M context) <noreply@anthropic.com>
</commit_message>
<xml_diff>
--- a/SLIDE_DECK.pptx
+++ b/SLIDE_DECK.pptx
@@ -24,6 +24,13 @@
     <p:sldId id="272" r:id="rId18"/>
     <p:sldId id="273" r:id="rId19"/>
     <p:sldId id="274" r:id="rId20"/>
+    <p:sldId id="275" r:id="rId21"/>
+    <p:sldId id="276" r:id="rId22"/>
+    <p:sldId id="277" r:id="rId23"/>
+    <p:sldId id="278" r:id="rId24"/>
+    <p:sldId id="279" r:id="rId25"/>
+    <p:sldId id="280" r:id="rId26"/>
+    <p:sldId id="281" r:id="rId27"/>
   </p:sldIdLst>
   <p:sldSz cx="9144000" cy="5143500" type="screen16x9"/>
   <p:notesSz cx="6858000" cy="9144000"/>
@@ -3216,7 +3223,7 @@
             </a:pPr>
             <a:r>
               <a:rPr/>
-              <a:t>Phase 4.5 — Seed Test Data (10 min)</a:t>
+              <a:t>Phase 2 — Extract to Markdown</a:t>
             </a:r>
           </a:p>
         </p:txBody>
@@ -3241,17 +3248,28 @@
             </a:pPr>
             <a:r>
               <a:rPr/>
-              <a:t>Generate </a:t>
-            </a:r>
-            <a:r>
-              <a:rPr>
-                <a:latin typeface="Courier"/>
-              </a:rPr>
-              <a:t>scripts/seed_data.sql</a:t>
-            </a:r>
-            <a:r>
-              <a:rPr/>
-              <a:t> covering every role, status, and enum value. Run it via MCP.</a:t>
+              <a:t>One prompt, Claude produces:</a:t>
+            </a:r>
+          </a:p>
+          <a:p>
+            <a:pPr lvl="0"/>
+            <a:r>
+              <a:rPr/>
+              <a:t>Organization, interviews, problems, BPMNs</a:t>
+            </a:r>
+          </a:p>
+          <a:p>
+            <a:pPr lvl="0"/>
+            <a:r>
+              <a:rPr/>
+              <a:t>Requirements + UC specs</a:t>
+            </a:r>
+          </a:p>
+          <a:p>
+            <a:pPr lvl="0"/>
+            <a:r>
+              <a:rPr/>
+              <a:t>Design diagrams (class, state, sequence)</a:t>
             </a:r>
           </a:p>
           <a:p>
@@ -3259,18 +3277,12 @@
               <a:buNone/>
             </a:pPr>
             <a:r>
-              <a:rPr/>
-              <a:t>Why now (before code): so when Phase 5’s </a:t>
-            </a:r>
-            <a:r>
-              <a:rPr>
-                <a:latin typeface="Courier"/>
-              </a:rPr>
-              <a:t>LoginPanel</a:t>
-            </a:r>
-            <a:r>
-              <a:rPr/>
-              <a:t> runs, there are actual users to log in as.</a:t>
+              <a:rPr b="1"/>
+              <a:t>Then review each file against the PDF.</a:t>
+            </a:r>
+            <a:r>
+              <a:rPr/>
+              <a:t> Counts, tables, wording — Claude drifts here.</a:t>
             </a:r>
           </a:p>
         </p:txBody>
@@ -3317,7 +3329,7 @@
             </a:pPr>
             <a:r>
               <a:rPr/>
-              <a:t>Phase 5 — C# Project Scaffold + Entry Flow (45 min)</a:t>
+              <a:t>Phase 3 — Generate CLAUDE.md</a:t>
             </a:r>
           </a:p>
         </p:txBody>
@@ -3337,156 +3349,61 @@
           <a:bodyPr/>
           <a:lstStyle/>
           <a:p>
-            <a:pPr lvl="0" indent="-342900" marL="342900">
-              <a:buAutoNum type="arabicPeriod"/>
-            </a:pPr>
-            <a:r>
-              <a:rPr b="1"/>
-              <a:t>5.1</a:t>
-            </a:r>
-            <a:r>
-              <a:rPr/>
-              <a:t> — Scaffold (</a:t>
+            <a:pPr lvl="0" indent="0" marL="0">
+              <a:buNone/>
+            </a:pPr>
+            <a:r>
+              <a:rPr/>
+              <a:t>Most important file in your project. Claude inlines </a:t>
             </a:r>
             <a:r>
               <a:rPr>
                 <a:latin typeface="Courier"/>
               </a:rPr>
-              <a:t>SharonaPilates.sln</a:t>
-            </a:r>
-            <a:r>
-              <a:rPr/>
-              <a:t> + </a:t>
-            </a:r>
-            <a:r>
-              <a:rPr>
-                <a:latin typeface="Courier"/>
-              </a:rPr>
-              <a:t>.csproj</a:t>
-            </a:r>
-            <a:r>
-              <a:rPr/>
-              <a:t> matching the sample)</a:t>
-            </a:r>
-          </a:p>
-          <a:p>
-            <a:pPr lvl="0" indent="-342900" marL="342900">
-              <a:buAutoNum type="arabicPeriod"/>
-            </a:pPr>
-            <a:r>
-              <a:rPr b="1"/>
-              <a:t>5.2</a:t>
-            </a:r>
-            <a:r>
-              <a:rPr/>
-              <a:t> — </a:t>
-            </a:r>
-            <a:r>
-              <a:rPr>
-                <a:latin typeface="Courier"/>
-              </a:rPr>
-              <a:t>SQL_CON.cs</a:t>
-            </a:r>
-            <a:r>
-              <a:rPr/>
-              <a:t> reads connection from </a:t>
-            </a:r>
-            <a:r>
-              <a:rPr>
-                <a:latin typeface="Courier"/>
-              </a:rPr>
-              <a:t>app.config</a:t>
-            </a:r>
-          </a:p>
-          <a:p>
-            <a:pPr lvl="0" indent="-342900" marL="342900">
-              <a:buAutoNum type="arabicPeriod"/>
-            </a:pPr>
-            <a:r>
-              <a:rPr b="1"/>
-              <a:t>5.3</a:t>
-            </a:r>
-            <a:r>
-              <a:rPr/>
-              <a:t> — Generate all entity classes + </a:t>
-            </a:r>
-            <a:r>
-              <a:rPr>
-                <a:latin typeface="Courier"/>
-              </a:rPr>
-              <a:t>Program.cs</a:t>
-            </a:r>
-            <a:r>
-              <a:rPr/>
-              <a:t> with load order</a:t>
-            </a:r>
-          </a:p>
-          <a:p>
-            <a:pPr lvl="0" indent="-342900" marL="342900">
-              <a:buAutoNum type="arabicPeriod"/>
-            </a:pPr>
-            <a:r>
-              <a:rPr b="1"/>
-              <a:t>5.4</a:t>
-            </a:r>
-            <a:r>
-              <a:rPr/>
-              <a:t> — Review entity hydration of object references</a:t>
-            </a:r>
-          </a:p>
-          <a:p>
-            <a:pPr lvl="0" indent="-342900" marL="342900">
-              <a:buAutoNum type="arabicPeriod"/>
-            </a:pPr>
-            <a:r>
-              <a:rPr b="1"/>
-              <a:t>5.5</a:t>
-            </a:r>
-            <a:r>
-              <a:rPr/>
-              <a:t> — </a:t>
-            </a:r>
-            <a:r>
-              <a:rPr b="1"/>
-              <a:t>Entry flow:</a:t>
-            </a:r>
-            <a:r>
-              <a:rPr/>
-              <a:t> Claude inspects actors → designs login + per-role homes</a:t>
-            </a:r>
-          </a:p>
-          <a:p>
-            <a:pPr lvl="0" indent="-342900" marL="342900">
-              <a:buAutoNum type="arabicPeriod"/>
-            </a:pPr>
-            <a:r>
-              <a:rPr b="1"/>
-              <a:t>5.6</a:t>
-            </a:r>
-            <a:r>
-              <a:rPr/>
-              <a:t> — Generate the first CRUD panel under the right role home</a:t>
-            </a:r>
-          </a:p>
-          <a:p>
-            <a:pPr lvl="0" indent="-342900" marL="342900">
-              <a:buAutoNum type="arabicPeriod"/>
-            </a:pPr>
-            <a:r>
-              <a:rPr b="1"/>
-              <a:t>5.7</a:t>
-            </a:r>
-            <a:r>
-              <a:rPr/>
-              <a:t> — </a:t>
-            </a:r>
-            <a:r>
-              <a:rPr b="1"/>
-              <a:t>F5.</a:t>
-            </a:r>
-            <a:r>
-              <a:rPr/>
-              <a:t> Login, navigate, CRUD, verify in DB.</a:t>
+              <a:t>PATTERNS.md</a:t>
+            </a:r>
+            <a:r>
+              <a:rPr/>
+              <a:t> + your domain.</a:t>
+            </a:r>
+          </a:p>
+          <a:p>
+            <a:pPr lvl="0" indent="0" marL="0">
+              <a:buNone/>
+            </a:pPr>
+            <a:r>
+              <a:rPr/>
+              <a:t>What to verify:</a:t>
+            </a:r>
+          </a:p>
+          <a:p>
+            <a:pPr lvl="0"/>
+            <a:r>
+              <a:rPr/>
+              <a:t>Implementation scope matches what you’ll code</a:t>
+            </a:r>
+          </a:p>
+          <a:p>
+            <a:pPr lvl="0"/>
+            <a:r>
+              <a:rPr/>
+              <a:t>Entity load order is correct</a:t>
+            </a:r>
+          </a:p>
+          <a:p>
+            <a:pPr lvl="0"/>
+            <a:r>
+              <a:rPr/>
+              <a:t>Group decisions are real (not invented)</a:t>
+            </a:r>
+          </a:p>
+          <a:p>
+            <a:pPr lvl="0" indent="0" marL="0">
+              <a:buNone/>
+            </a:pPr>
+            <a:r>
+              <a:rPr/>
+              <a:t>Don’t fuss over attribute names — compiler catches those later.</a:t>
             </a:r>
           </a:p>
         </p:txBody>
@@ -3533,7 +3450,7 @@
             </a:pPr>
             <a:r>
               <a:rPr/>
-              <a:t>Phase 5.5 — The Entry Flow Decision</a:t>
+              <a:t>Phase 4 — Schema + SPs</a:t>
             </a:r>
           </a:p>
         </p:txBody>
@@ -3553,75 +3470,86 @@
           <a:bodyPr/>
           <a:lstStyle/>
           <a:p>
-            <a:pPr lvl="0" indent="0" marL="0">
-              <a:buNone/>
-            </a:pPr>
-            <a:r>
-              <a:rPr/>
-              <a:t>Login is </a:t>
-            </a:r>
-            <a:r>
-              <a:rPr b="1"/>
-              <a:t>not</a:t>
-            </a:r>
-            <a:r>
-              <a:rPr/>
-              <a:t> a UC, but it </a:t>
-            </a:r>
-            <a:r>
-              <a:rPr b="1"/>
-              <a:t>is</a:t>
-            </a:r>
-            <a:r>
-              <a:rPr/>
-              <a:t> the first screen.</a:t>
-            </a:r>
-          </a:p>
-          <a:p>
-            <a:pPr lvl="0" indent="0" marL="0">
-              <a:buNone/>
-            </a:pPr>
-            <a:r>
-              <a:rPr/>
-              <a:t>Claude reads the class diagram to find credential-holding entities (e.g., </a:t>
+            <a:pPr lvl="0" indent="-342900" marL="342900">
+              <a:buAutoNum type="arabicPeriod"/>
+            </a:pPr>
+            <a:r>
+              <a:rPr/>
+              <a:t>Create the project DB (4.0)</a:t>
+            </a:r>
+          </a:p>
+          <a:p>
+            <a:pPr lvl="0" indent="-342900" marL="342900">
+              <a:buAutoNum type="arabicPeriod"/>
+            </a:pPr>
+            <a:r>
+              <a:rPr/>
+              <a:t>Generate </a:t>
             </a:r>
             <a:r>
               <a:rPr>
                 <a:latin typeface="Courier"/>
               </a:rPr>
-              <a:t>UserProfile</a:t>
-            </a:r>
-            <a:r>
-              <a:rPr/>
-              <a:t>, </a:t>
+              <a:t>create_database.sql</a:t>
+            </a:r>
+            <a:r>
+              <a:rPr/>
+              <a:t> (4.1)</a:t>
+            </a:r>
+          </a:p>
+          <a:p>
+            <a:pPr lvl="0" indent="-342900" marL="342900">
+              <a:buAutoNum type="arabicPeriod"/>
+            </a:pPr>
+            <a:r>
+              <a:rPr/>
+              <a:t>Review against class diagram (4.2)</a:t>
+            </a:r>
+          </a:p>
+          <a:p>
+            <a:pPr lvl="0" indent="-342900" marL="342900">
+              <a:buAutoNum type="arabicPeriod"/>
+            </a:pPr>
+            <a:r>
+              <a:rPr/>
+              <a:t>Run via MCP (4.3)</a:t>
+            </a:r>
+          </a:p>
+          <a:p>
+            <a:pPr lvl="0" indent="0" marL="0">
+              <a:buNone/>
+            </a:pPr>
+            <a:r>
+              <a:rPr/>
+              <a:t>Then SPs:</a:t>
+            </a:r>
+          </a:p>
+          <a:p>
+            <a:pPr lvl="0" indent="-342900" marL="342900">
+              <a:buAutoNum startAt="5" type="arabicPeriod"/>
+            </a:pPr>
+            <a:r>
+              <a:rPr/>
+              <a:t>Generate </a:t>
             </a:r>
             <a:r>
               <a:rPr>
                 <a:latin typeface="Courier"/>
               </a:rPr>
-              <a:t>Employee</a:t>
-            </a:r>
-            <a:r>
-              <a:rPr/>
-              <a:t>). Each becomes a login source. Each routes to its own home panel.</a:t>
-            </a:r>
-          </a:p>
-          <a:p>
-            <a:pPr lvl="0" indent="0" marL="0">
-              <a:buNone/>
-            </a:pPr>
-            <a:r>
-              <a:rPr/>
-              <a:t>Claude proposes the design and waits for your confirmation before writing files.</a:t>
-            </a:r>
-          </a:p>
-          <a:p>
-            <a:pPr lvl="0" indent="0" marL="0">
-              <a:buNone/>
-            </a:pPr>
-            <a:r>
-              <a:rPr/>
-              <a:t>This is where your design diagrams pay off visually — students see actors become routes.</a:t>
+              <a:t>stored_procedures.sql</a:t>
+            </a:r>
+            <a:r>
+              <a:rPr/>
+              <a:t> (4.4)</a:t>
+            </a:r>
+          </a:p>
+          <a:p>
+            <a:pPr lvl="0" indent="-342900" marL="342900">
+              <a:buAutoNum startAt="5" type="arabicPeriod"/>
+            </a:pPr>
+            <a:r>
+              <a:rPr/>
+              <a:t>Spot-check one entity’s CRUD (4.5)</a:t>
             </a:r>
           </a:p>
         </p:txBody>
@@ -3668,7 +3596,7 @@
             </a:pPr>
             <a:r>
               <a:rPr/>
-              <a:t>Phase 6 — Remaining CRUD Panels (20 min)</a:t>
+              <a:t>Phase 4 — Key Conventions</a:t>
             </a:r>
           </a:p>
         </p:txBody>
@@ -3688,47 +3616,118 @@
           <a:bodyPr/>
           <a:lstStyle/>
           <a:p>
+            <a:pPr lvl="0"/>
+            <a:r>
+              <a:rPr b="1"/>
+              <a:t>PKs assigned in C#, not by DB.</a:t>
+            </a:r>
+            <a:r>
+              <a:rPr/>
+              <a:t> No </a:t>
+            </a:r>
+            <a:r>
+              <a:rPr>
+                <a:latin typeface="Courier"/>
+              </a:rPr>
+              <a:t>IDENTITY</a:t>
+            </a:r>
+            <a:r>
+              <a:rPr/>
+              <a:t>.</a:t>
+            </a:r>
+          </a:p>
+          <a:p>
+            <a:pPr lvl="0"/>
+            <a:r>
+              <a:rPr b="1">
+                <a:latin typeface="Courier"/>
+              </a:rPr>
+              <a:t>NVARCHAR</a:t>
+            </a:r>
+            <a:r>
+              <a:rPr b="1"/>
+              <a:t>, never </a:t>
+            </a:r>
+            <a:r>
+              <a:rPr b="1">
+                <a:latin typeface="Courier"/>
+              </a:rPr>
+              <a:t>VARCHAR</a:t>
+            </a:r>
+            <a:r>
+              <a:rPr b="1"/>
+              <a:t>.</a:t>
+            </a:r>
+            <a:r>
+              <a:rPr/>
+              <a:t> Always.</a:t>
+            </a:r>
+          </a:p>
+          <a:p>
+            <a:pPr lvl="0"/>
+            <a:r>
+              <a:rPr b="1"/>
+              <a:t>Hebrew literals prefixed </a:t>
+            </a:r>
+            <a:r>
+              <a:rPr b="1">
+                <a:latin typeface="Courier"/>
+              </a:rPr>
+              <a:t>N'...'</a:t>
+            </a:r>
+            <a:r>
+              <a:rPr b="1"/>
+              <a:t>.</a:t>
+            </a:r>
+          </a:p>
+          <a:p>
+            <a:pPr lvl="0"/>
+            <a:r>
+              <a:rPr b="1"/>
+              <a:t>Every SP takes its PK as a parameter.</a:t>
+            </a:r>
+            <a:r>
+              <a:rPr/>
+              <a:t> No </a:t>
+            </a:r>
+            <a:r>
+              <a:rPr>
+                <a:latin typeface="Courier"/>
+              </a:rPr>
+              <a:t>SCOPE_IDENTITY()</a:t>
+            </a:r>
+            <a:r>
+              <a:rPr/>
+              <a:t>.</a:t>
+            </a:r>
+          </a:p>
+          <a:p>
             <a:pPr lvl="0" indent="0" marL="0">
               <a:buNone/>
             </a:pPr>
             <a:r>
               <a:rPr/>
-              <a:t>Two paths, pick one:</a:t>
-            </a:r>
-          </a:p>
-          <a:p>
-            <a:pPr lvl="0" indent="0" marL="0">
-              <a:buNone/>
-            </a:pPr>
-            <a:r>
-              <a:rPr b="1"/>
-              <a:t>Option A — One at a time.</a:t>
-            </a:r>
-            <a:r>
-              <a:rPr/>
-              <a:t> Cautious. Generate, review, wire, build. Repeat.</a:t>
-            </a:r>
-          </a:p>
-          <a:p>
-            <a:pPr lvl="0" indent="0" marL="0">
-              <a:buNone/>
-            </a:pPr>
-            <a:r>
-              <a:rPr b="1"/>
-              <a:t>Option B — All at once.</a:t>
-            </a:r>
-            <a:r>
-              <a:rPr/>
-              <a:t> Dramatic. One prompt → 8–10 panels in a single batch. Token-cheaper, more impressive demo, but errors propagate.</a:t>
-            </a:r>
-          </a:p>
-          <a:p>
-            <a:pPr lvl="0" indent="0" marL="0">
-              <a:buNone/>
-            </a:pPr>
-            <a:r>
-              <a:rPr/>
-              <a:t>Either way, walk through every panel after generation: build clean, F5 sweep, spot-check one create/update/delete per role.</a:t>
+              <a:t>These live in </a:t>
+            </a:r>
+            <a:r>
+              <a:rPr>
+                <a:latin typeface="Courier"/>
+              </a:rPr>
+              <a:t>PATTERNS.md</a:t>
+            </a:r>
+            <a:r>
+              <a:rPr/>
+              <a:t> and get inlined into your </a:t>
+            </a:r>
+            <a:r>
+              <a:rPr>
+                <a:latin typeface="Courier"/>
+              </a:rPr>
+              <a:t>CLAUDE.md</a:t>
+            </a:r>
+            <a:r>
+              <a:rPr/>
+              <a:t>.</a:t>
             </a:r>
           </a:p>
         </p:txBody>
@@ -3775,7 +3774,7 @@
             </a:pPr>
             <a:r>
               <a:rPr/>
-              <a:t>Phase 7 — State Machines (in class if time)</a:t>
+              <a:t>Phase 4.5 — Seed Data</a:t>
             </a:r>
           </a:p>
         </p:txBody>
@@ -3800,50 +3799,17 @@
             </a:pPr>
             <a:r>
               <a:rPr/>
-              <a:t>CRUD treats entities as bags of fields. State machines introduce:</a:t>
-            </a:r>
-          </a:p>
-          <a:p>
-            <a:pPr lvl="0"/>
-            <a:r>
-              <a:rPr b="1"/>
-              <a:t>Guards</a:t>
-            </a:r>
-            <a:r>
-              <a:rPr/>
-              <a:t> — not every transition is always legal</a:t>
-            </a:r>
-          </a:p>
-          <a:p>
-            <a:pPr lvl="0"/>
-            <a:r>
-              <a:rPr b="1"/>
-              <a:t>Side effects</a:t>
-            </a:r>
-            <a:r>
-              <a:rPr/>
-              <a:t> — cancelling a registration frees a slot, refunds a credit, may promote a waitlist</a:t>
-            </a:r>
-          </a:p>
-          <a:p>
-            <a:pPr lvl="0"/>
-            <a:r>
-              <a:rPr b="1"/>
-              <a:t>Atomicity</a:t>
-            </a:r>
-            <a:r>
-              <a:rPr/>
-              <a:t> — </a:t>
+              <a:t>Generate </a:t>
             </a:r>
             <a:r>
               <a:rPr>
                 <a:latin typeface="Courier"/>
               </a:rPr>
-              <a:t>BEGIN TRAN ... COMMIT</a:t>
-            </a:r>
-            <a:r>
-              <a:rPr/>
-              <a:t> so partial failures roll back</a:t>
+              <a:t>seed_data.sql</a:t>
+            </a:r>
+            <a:r>
+              <a:rPr/>
+              <a:t> covering every role, status, and enum.</a:t>
             </a:r>
           </a:p>
           <a:p>
@@ -3852,7 +3818,7 @@
             </a:pPr>
             <a:r>
               <a:rPr/>
-              <a:t>Where your state diagrams from design class become running code.</a:t>
+              <a:t>~5–10 rows per base table, ~10–20 for transactional/association tables.</a:t>
             </a:r>
           </a:p>
           <a:p>
@@ -3860,16 +3826,22 @@
               <a:buNone/>
             </a:pPr>
             <a:r>
-              <a:rPr/>
-              <a:t>Each user-triggered transition gets a </a:t>
-            </a:r>
-            <a:r>
               <a:rPr b="1"/>
-              <a:t>verb button</a:t>
-            </a:r>
-            <a:r>
-              <a:rPr/>
-              <a:t> (“ביטול הרשמה”), not a generic Update.</a:t>
+              <a:t>Why now (before code):</a:t>
+            </a:r>
+            <a:r>
+              <a:rPr/>
+              <a:t> so when Phase 5’s </a:t>
+            </a:r>
+            <a:r>
+              <a:rPr>
+                <a:latin typeface="Courier"/>
+              </a:rPr>
+              <a:t>LoginPanel</a:t>
+            </a:r>
+            <a:r>
+              <a:rPr/>
+              <a:t> runs, there are real users to log in as.</a:t>
             </a:r>
           </a:p>
         </p:txBody>
@@ -3916,7 +3888,7 @@
             </a:pPr>
             <a:r>
               <a:rPr/>
-              <a:t>Phases 8–11 — Homework</a:t>
+              <a:t>Phase 5 — C# Scaffold</a:t>
             </a:r>
           </a:p>
         </p:txBody>
@@ -3936,66 +3908,77 @@
           <a:bodyPr/>
           <a:lstStyle/>
           <a:p>
-            <a:pPr lvl="0" indent="0" marL="0">
-              <a:buNone/>
-            </a:pPr>
-            <a:r>
-              <a:rPr/>
-              <a:t>Documented in </a:t>
+            <a:pPr lvl="0"/>
+            <a:r>
+              <a:rPr/>
+              <a:t>5.1 — </a:t>
             </a:r>
             <a:r>
               <a:rPr>
                 <a:latin typeface="Courier"/>
               </a:rPr>
-              <a:t>LESSON_STEPS.md</a:t>
-            </a:r>
-            <a:r>
-              <a:rPr/>
-              <a:t> with full prompts. Not covered in class:</a:t>
+              <a:t>.sln</a:t>
+            </a:r>
+            <a:r>
+              <a:rPr/>
+              <a:t> + </a:t>
+            </a:r>
+            <a:r>
+              <a:rPr>
+                <a:latin typeface="Courier"/>
+              </a:rPr>
+              <a:t>.csproj</a:t>
+            </a:r>
+            <a:r>
+              <a:rPr/>
+              <a:t> mirroring the sample</a:t>
             </a:r>
           </a:p>
           <a:p>
             <a:pPr lvl="0"/>
             <a:r>
-              <a:rPr b="1"/>
-              <a:t>Phase 8</a:t>
-            </a:r>
-            <a:r>
-              <a:rPr/>
-              <a:t> — Reports: read-only, parameterized, aggregated. Different shape from CRUD.</a:t>
+              <a:rPr/>
+              <a:t>5.2 — </a:t>
+            </a:r>
+            <a:r>
+              <a:rPr>
+                <a:latin typeface="Courier"/>
+              </a:rPr>
+              <a:t>SQL_CON.cs</a:t>
+            </a:r>
+            <a:r>
+              <a:rPr/>
+              <a:t> reading from </a:t>
+            </a:r>
+            <a:r>
+              <a:rPr>
+                <a:latin typeface="Courier"/>
+              </a:rPr>
+              <a:t>app.config</a:t>
             </a:r>
           </a:p>
           <a:p>
             <a:pPr lvl="0"/>
             <a:r>
-              <a:rPr b="1"/>
-              <a:t>Phase 9</a:t>
-            </a:r>
-            <a:r>
-              <a:rPr/>
-              <a:t> — Complex UC flows: multi-entity orchestrated transactions.</a:t>
+              <a:rPr/>
+              <a:t>5.3 — All entity classes + </a:t>
+            </a:r>
+            <a:r>
+              <a:rPr>
+                <a:latin typeface="Courier"/>
+              </a:rPr>
+              <a:t>Program.cs</a:t>
+            </a:r>
+            <a:r>
+              <a:rPr/>
+              <a:t> with load order</a:t>
             </a:r>
           </a:p>
           <a:p>
             <a:pPr lvl="0"/>
             <a:r>
-              <a:rPr b="1"/>
-              <a:t>Phase 10</a:t>
-            </a:r>
-            <a:r>
-              <a:rPr/>
-              <a:t> — UI polish: feed Claude screenshots + references, get richer designs.</a:t>
-            </a:r>
-          </a:p>
-          <a:p>
-            <a:pPr lvl="0"/>
-            <a:r>
-              <a:rPr b="1"/>
-              <a:t>Phase 11</a:t>
-            </a:r>
-            <a:r>
-              <a:rPr/>
-              <a:t> — Switching to a shared DB (BGU central or free Azure SQL).</a:t>
+              <a:rPr/>
+              <a:t>5.4 — Review entity hydration</a:t>
             </a:r>
           </a:p>
           <a:p>
@@ -4004,7 +3987,7 @@
             </a:pPr>
             <a:r>
               <a:rPr/>
-              <a:t>You have the patterns; you have the tools. Phase 8–11 are just “ask Claude to do X following the same shape.”</a:t>
+              <a:t>Build should fail expectedly until 5.5 (no entry point yet).</a:t>
             </a:r>
           </a:p>
         </p:txBody>
@@ -4051,7 +4034,7 @@
             </a:pPr>
             <a:r>
               <a:rPr/>
-              <a:t>The Review Discipline</a:t>
+              <a:t>Phase 5.5 — The Entry Flow</a:t>
             </a:r>
           </a:p>
         </p:txBody>
@@ -4076,15 +4059,23 @@
             </a:pPr>
             <a:r>
               <a:rPr/>
-              <a:t>Catch errors that </a:t>
+              <a:t>Login is </a:t>
             </a:r>
             <a:r>
               <a:rPr b="1"/>
-              <a:t>won’t</a:t>
-            </a:r>
-            <a:r>
-              <a:rPr/>
-              <a:t> surface later. Skip ones the compiler will catch.</a:t>
+              <a:t>not</a:t>
+            </a:r>
+            <a:r>
+              <a:rPr/>
+              <a:t> a UC. But it </a:t>
+            </a:r>
+            <a:r>
+              <a:rPr b="1"/>
+              <a:t>is</a:t>
+            </a:r>
+            <a:r>
+              <a:rPr/>
+              <a:t> the first screen.</a:t>
             </a:r>
           </a:p>
           <a:p>
@@ -4092,12 +4083,8 @@
               <a:buNone/>
             </a:pPr>
             <a:r>
-              <a:rPr b="1"/>
-              <a:t>Catch now:</a:t>
-            </a:r>
-            <a:r>
-              <a:rPr/>
-              <a:t> - Implementation scope - Load order / FK ordering - Group decisions - Counts and lists - Silent conflicts between documents</a:t>
+              <a:rPr/>
+              <a:t>Claude reads the class diagram → finds credential-holding entities → designs login + per-role homes.</a:t>
             </a:r>
           </a:p>
           <a:p>
@@ -4105,12 +4092,17 @@
               <a:buNone/>
             </a:pPr>
             <a:r>
-              <a:rPr b="1"/>
-              <a:t>Don’t bother:</a:t>
-            </a:r>
-            <a:r>
-              <a:rPr/>
-              <a:t> - Attribute names (compile error first time they’re used) - Enum values (same) - Method signatures (same) - Minor wording</a:t>
+              <a:rPr/>
+              <a:t>Claude proposes the design and waits for your confirmation before writing files.</a:t>
+            </a:r>
+          </a:p>
+          <a:p>
+            <a:pPr lvl="0" indent="0" marL="0">
+              <a:buNone/>
+            </a:pPr>
+            <a:r>
+              <a:rPr/>
+              <a:t>Where your design diagrams pay off visually.</a:t>
             </a:r>
           </a:p>
         </p:txBody>
@@ -4157,7 +4149,7 @@
             </a:pPr>
             <a:r>
               <a:rPr/>
-              <a:t>Working With Claude — Principles</a:t>
+              <a:t>Phase 5.6 + 5.7 — First Panel and Run</a:t>
             </a:r>
           </a:p>
         </p:txBody>
@@ -4177,98 +4169,30 @@
           <a:bodyPr/>
           <a:lstStyle/>
           <a:p>
-            <a:pPr lvl="0" indent="-342900" marL="342900">
-              <a:buAutoNum type="arabicPeriod"/>
-            </a:pPr>
-            <a:r>
-              <a:rPr b="1"/>
-              <a:t>Always ask Claude before doing it yourself.</a:t>
-            </a:r>
-            <a:r>
-              <a:rPr/>
-              <a:t> File edits, SQL runs, builds — let Claude do the work, you review.</a:t>
-            </a:r>
-          </a:p>
-          <a:p>
-            <a:pPr lvl="0" indent="-342900" marL="342900">
-              <a:buAutoNum type="arabicPeriod"/>
-            </a:pPr>
-            <a:r>
-              <a:rPr b="1"/>
-              <a:t>Push back specifically.</a:t>
-            </a:r>
-            <a:r>
-              <a:rPr/>
-              <a:t> “The problems table has 5 rows, the PDF has 10. Re-read pages 3–4 and reconcile.”</a:t>
-            </a:r>
-          </a:p>
-          <a:p>
-            <a:pPr lvl="0" indent="-342900" marL="342900">
-              <a:buAutoNum type="arabicPeriod"/>
-            </a:pPr>
-            <a:r>
-              <a:rPr b="1"/>
-              <a:t>Sources of truth are files, not memory.</a:t>
-            </a:r>
-            <a:r>
-              <a:rPr/>
-              <a:t> Persist decisions in </a:t>
-            </a:r>
-            <a:r>
-              <a:rPr>
-                <a:latin typeface="Courier"/>
-              </a:rPr>
-              <a:t>CLAUDE.md</a:t>
-            </a:r>
-            <a:r>
-              <a:rPr/>
-              <a:t> so future sessions inherit them.</a:t>
-            </a:r>
-          </a:p>
-          <a:p>
-            <a:pPr lvl="0" indent="-342900" marL="342900">
-              <a:buAutoNum type="arabicPeriod"/>
-            </a:pPr>
-            <a:r>
-              <a:rPr b="1"/>
-              <a:t>Never commit </a:t>
-            </a:r>
-            <a:r>
-              <a:rPr b="1">
-                <a:latin typeface="Courier"/>
-              </a:rPr>
-              <a:t>.mcp.json</a:t>
-            </a:r>
-            <a:r>
-              <a:rPr b="1"/>
-              <a:t> or </a:t>
-            </a:r>
-            <a:r>
-              <a:rPr b="1">
-                <a:latin typeface="Courier"/>
-              </a:rPr>
-              <a:t>app.config</a:t>
-            </a:r>
-            <a:r>
-              <a:rPr b="1"/>
-              <a:t>.</a:t>
-            </a:r>
-            <a:r>
-              <a:rPr/>
-              <a:t> They contain credentials.</a:t>
-            </a:r>
-          </a:p>
-          <a:p>
-            <a:pPr lvl="0" indent="-342900" marL="342900">
-              <a:buAutoNum type="arabicPeriod"/>
-            </a:pPr>
-            <a:r>
-              <a:rPr b="1"/>
-              <a:t>One prompt per concern.</a:t>
-            </a:r>
-            <a:r>
-              <a:rPr/>
-              <a:t> If you’re combining “generate this AND change that AND review that AND deploy that,” split it up.</a:t>
+            <a:pPr lvl="0" indent="0" marL="0">
+              <a:buNone/>
+            </a:pPr>
+            <a:r>
+              <a:rPr/>
+              <a:t>5.6 — Generate the first CRUD panel for a Tier 1 base entity. Wire under the right role’s home.</a:t>
+            </a:r>
+          </a:p>
+          <a:p>
+            <a:pPr lvl="0" indent="0" marL="0">
+              <a:buNone/>
+            </a:pPr>
+            <a:r>
+              <a:rPr/>
+              <a:t>5.7 — Build, F5, walk through: login → role home → CRUD → verify in DB via MCP.</a:t>
+            </a:r>
+          </a:p>
+          <a:p>
+            <a:pPr lvl="0" indent="0" marL="0">
+              <a:buNone/>
+            </a:pPr>
+            <a:r>
+              <a:rPr/>
+              <a:t>This is the “wow” moment. Login screen, real role routing, working CRUD.</a:t>
             </a:r>
           </a:p>
         </p:txBody>
@@ -4315,7 +4239,7 @@
             </a:pPr>
             <a:r>
               <a:rPr/>
-              <a:t>What to Take Home</a:t>
+              <a:t>Phase 6 — Remaining CRUDs</a:t>
             </a:r>
           </a:p>
         </p:txBody>
@@ -4335,66 +4259,47 @@
           <a:bodyPr/>
           <a:lstStyle/>
           <a:p>
-            <a:pPr lvl="0"/>
-            <a:r>
-              <a:rPr>
-                <a:latin typeface="Courier"/>
-              </a:rPr>
-              <a:t>PREREQS.md</a:t>
-            </a:r>
-            <a:r>
-              <a:rPr/>
-              <a:t> — install once, never re-install</a:t>
-            </a:r>
-          </a:p>
-          <a:p>
-            <a:pPr lvl="0"/>
-            <a:r>
-              <a:rPr>
-                <a:latin typeface="Courier"/>
-              </a:rPr>
-              <a:t>LESSON_STEPS.md</a:t>
-            </a:r>
-            <a:r>
-              <a:rPr/>
-              <a:t> — the full reference, with the </a:t>
-            </a:r>
-            <a:r>
-              <a:rPr i="1"/>
-              <a:t>why</a:t>
-            </a:r>
-            <a:r>
-              <a:rPr/>
-              <a:t> behind each step</a:t>
-            </a:r>
-          </a:p>
-          <a:p>
-            <a:pPr lvl="0"/>
-            <a:r>
-              <a:rPr>
-                <a:latin typeface="Courier"/>
-              </a:rPr>
-              <a:t>PROMPTS_CHEATSHEET.md</a:t>
-            </a:r>
-            <a:r>
-              <a:rPr/>
-              <a:t> — every prompt in copy-paste form</a:t>
-            </a:r>
-          </a:p>
-          <a:p>
-            <a:pPr lvl="0"/>
-            <a:r>
-              <a:rPr/>
-              <a:t>Your group’s project, with a working CLAUDE.md and a runnable first panel</a:t>
-            </a:r>
-          </a:p>
-          <a:p>
             <a:pPr lvl="0" indent="0" marL="0">
               <a:buNone/>
             </a:pPr>
             <a:r>
               <a:rPr/>
-              <a:t>After class: pick up at Phase 6 (if you didn’t finish), then push through 8–11 over the semester.</a:t>
+              <a:t>Two paths:</a:t>
+            </a:r>
+          </a:p>
+          <a:p>
+            <a:pPr lvl="0" indent="0" marL="0">
+              <a:buNone/>
+            </a:pPr>
+            <a:r>
+              <a:rPr b="1"/>
+              <a:t>Option A — One at a time.</a:t>
+            </a:r>
+            <a:r>
+              <a:rPr/>
+              <a:t> Cautious. Generate, review, build, repeat.</a:t>
+            </a:r>
+          </a:p>
+          <a:p>
+            <a:pPr lvl="0" indent="0" marL="0">
+              <a:buNone/>
+            </a:pPr>
+            <a:r>
+              <a:rPr b="1"/>
+              <a:t>Option B — All at once.</a:t>
+            </a:r>
+            <a:r>
+              <a:rPr/>
+              <a:t> Dramatic. One prompt → 8–10 panels in one batch.</a:t>
+            </a:r>
+          </a:p>
+          <a:p>
+            <a:pPr lvl="0" indent="0" marL="0">
+              <a:buNone/>
+            </a:pPr>
+            <a:r>
+              <a:rPr/>
+              <a:t>Either way, sweep through every panel after. Spot-check create/update/delete on a couple.</a:t>
             </a:r>
           </a:p>
         </p:txBody>
@@ -4441,7 +4346,7 @@
             </a:pPr>
             <a:r>
               <a:rPr/>
-              <a:t>Questions?</a:t>
+              <a:t>Phase 7 — State Machines</a:t>
             </a:r>
           </a:p>
         </p:txBody>
@@ -4466,13 +4371,46 @@
             </a:pPr>
             <a:r>
               <a:rPr/>
-              <a:t>Repo: </a:t>
+              <a:t>CRUD treats entities as bags of fields. State machines add:</a:t>
+            </a:r>
+          </a:p>
+          <a:p>
+            <a:pPr lvl="0"/>
+            <a:r>
+              <a:rPr b="1"/>
+              <a:t>Guards</a:t>
+            </a:r>
+            <a:r>
+              <a:rPr/>
+              <a:t> — not every transition is always legal</a:t>
+            </a:r>
+          </a:p>
+          <a:p>
+            <a:pPr lvl="0"/>
+            <a:r>
+              <a:rPr b="1"/>
+              <a:t>Side effects</a:t>
+            </a:r>
+            <a:r>
+              <a:rPr/>
+              <a:t> — cancel a registration → free slot + refund credit</a:t>
+            </a:r>
+          </a:p>
+          <a:p>
+            <a:pPr lvl="0"/>
+            <a:r>
+              <a:rPr b="1"/>
+              <a:t>Atomicity</a:t>
+            </a:r>
+            <a:r>
+              <a:rPr/>
+              <a:t> — </a:t>
             </a:r>
             <a:r>
               <a:rPr>
-                <a:hlinkClick r:id="rId2"/>
+                <a:latin typeface="Courier"/>
               </a:rPr>
-              <a:t>https://github.com/dcodish/SAD-sample-project</a:t>
+              <a:t>BEGIN TRAN … COMMIT</a:t>
             </a:r>
           </a:p>
           <a:p>
@@ -4481,7 +4419,7 @@
             </a:pPr>
             <a:r>
               <a:rPr/>
-              <a:t>When stuck: paste the error into Claude Code, it has full context. If Claude can’t solve it, the course group chat is your next stop.</a:t>
+              <a:t>Each user-triggered transition gets a verb button, not a generic Update.</a:t>
             </a:r>
           </a:p>
         </p:txBody>
@@ -4548,56 +4486,876 @@
           <a:bodyPr/>
           <a:lstStyle/>
           <a:p>
+            <a:pPr lvl="0"/>
+            <a:r>
+              <a:rPr/>
+              <a:t>A working SQL Server database with seed data</a:t>
+            </a:r>
+          </a:p>
+          <a:p>
+            <a:pPr lvl="0"/>
+            <a:r>
+              <a:rPr/>
+              <a:t>A C# WinForms project running on your machine</a:t>
+            </a:r>
+          </a:p>
+          <a:p>
+            <a:pPr lvl="0"/>
+            <a:r>
+              <a:rPr/>
+              <a:t>Login screen + 2–3 CRUD screens</a:t>
+            </a:r>
+          </a:p>
+          <a:p>
+            <a:pPr lvl="0"/>
+            <a:r>
+              <a:rPr/>
+              <a:t>Everything driven from Claude Code</a:t>
+            </a:r>
+          </a:p>
+        </p:txBody>
+      </p:sp>
+    </p:spTree>
+  </p:cSld>
+</p:sld>
+</file>
+
+<file path=ppt/slides/slide20.xml><?xml version="1.0" encoding="utf-8"?>
+<p:sld xmlns:a="http://schemas.openxmlformats.org/drawingml/2006/main" xmlns:r="http://schemas.openxmlformats.org/officeDocument/2006/relationships" xmlns:p="http://schemas.openxmlformats.org/presentationml/2006/main">
+  <p:cSld>
+    <p:spTree>
+      <p:nvGrpSpPr>
+        <p:cNvPr id="1" name=""/>
+        <p:cNvGrpSpPr/>
+        <p:nvPr/>
+      </p:nvGrpSpPr>
+      <p:grpSpPr>
+        <a:xfrm>
+          <a:off x="0" y="0"/>
+          <a:ext cx="0" cy="0"/>
+          <a:chOff x="0" y="0"/>
+          <a:chExt cx="0" cy="0"/>
+        </a:xfrm>
+      </p:grpSpPr>
+      <p:sp>
+        <p:nvSpPr>
+          <p:cNvPr id="2" name="Title 1"/>
+          <p:cNvSpPr>
+            <a:spLocks noGrp="1"/>
+          </p:cNvSpPr>
+          <p:nvPr>
+            <p:ph type="title"/>
+          </p:nvPr>
+        </p:nvSpPr>
+        <p:spPr/>
+        <p:txBody>
+          <a:bodyPr/>
+          <a:lstStyle/>
+          <a:p>
             <a:pPr lvl="0" indent="0" marL="0">
               <a:buNone/>
             </a:pPr>
             <a:r>
               <a:rPr/>
-              <a:t>By the end of this class:</a:t>
+              <a:t>Phase 7 — Why It Matters</a:t>
+            </a:r>
+          </a:p>
+        </p:txBody>
+      </p:sp>
+      <p:sp>
+        <p:nvSpPr>
+          <p:cNvPr id="3" name="Content Placeholder 2"/>
+          <p:cNvSpPr>
+            <a:spLocks noGrp="1"/>
+          </p:cNvSpPr>
+          <p:nvPr>
+            <p:ph idx="1"/>
+          </p:nvPr>
+        </p:nvSpPr>
+        <p:spPr/>
+        <p:txBody>
+          <a:bodyPr/>
+          <a:lstStyle/>
+          <a:p>
+            <a:pPr lvl="0" indent="0" marL="0">
+              <a:buNone/>
+            </a:pPr>
+            <a:r>
+              <a:rPr/>
+              <a:t>Your state diagrams from design class become </a:t>
+            </a:r>
+            <a:r>
+              <a:rPr b="1"/>
+              <a:t>running code</a:t>
+            </a:r>
+            <a:r>
+              <a:rPr/>
+              <a:t>.</a:t>
+            </a:r>
+          </a:p>
+          <a:p>
+            <a:pPr lvl="0" indent="0" marL="0">
+              <a:buNone/>
+            </a:pPr>
+            <a:r>
+              <a:rPr/>
+              <a:t>If you only do CRUD, students can manually set </a:t>
+            </a:r>
+            <a:r>
+              <a:rPr>
+                <a:latin typeface="Courier"/>
+              </a:rPr>
+              <a:t>status = 'Cancelled'</a:t>
+            </a:r>
+            <a:r>
+              <a:rPr/>
+              <a:t> and silently skip all guards — broken domain.</a:t>
+            </a:r>
+          </a:p>
+          <a:p>
+            <a:pPr lvl="0" indent="0" marL="0">
+              <a:buNone/>
+            </a:pPr>
+            <a:r>
+              <a:rPr/>
+              <a:t>State machines are where business logic lives in code, not in screens.</a:t>
+            </a:r>
+          </a:p>
+        </p:txBody>
+      </p:sp>
+    </p:spTree>
+  </p:cSld>
+</p:sld>
+</file>
+
+<file path=ppt/slides/slide21.xml><?xml version="1.0" encoding="utf-8"?>
+<p:sld xmlns:a="http://schemas.openxmlformats.org/drawingml/2006/main" xmlns:r="http://schemas.openxmlformats.org/officeDocument/2006/relationships" xmlns:p="http://schemas.openxmlformats.org/presentationml/2006/main">
+  <p:cSld>
+    <p:spTree>
+      <p:nvGrpSpPr>
+        <p:cNvPr id="1" name=""/>
+        <p:cNvGrpSpPr/>
+        <p:nvPr/>
+      </p:nvGrpSpPr>
+      <p:grpSpPr>
+        <a:xfrm>
+          <a:off x="0" y="0"/>
+          <a:ext cx="0" cy="0"/>
+          <a:chOff x="0" y="0"/>
+          <a:chExt cx="0" cy="0"/>
+        </a:xfrm>
+      </p:grpSpPr>
+      <p:sp>
+        <p:nvSpPr>
+          <p:cNvPr id="2" name="Title 1"/>
+          <p:cNvSpPr>
+            <a:spLocks noGrp="1"/>
+          </p:cNvSpPr>
+          <p:nvPr>
+            <p:ph type="title"/>
+          </p:nvPr>
+        </p:nvSpPr>
+        <p:spPr/>
+        <p:txBody>
+          <a:bodyPr/>
+          <a:lstStyle/>
+          <a:p>
+            <a:pPr lvl="0" indent="0" marL="0">
+              <a:buNone/>
+            </a:pPr>
+            <a:r>
+              <a:rPr/>
+              <a:t>Phases 8–11 — Homework</a:t>
+            </a:r>
+          </a:p>
+        </p:txBody>
+      </p:sp>
+      <p:sp>
+        <p:nvSpPr>
+          <p:cNvPr id="3" name="Content Placeholder 2"/>
+          <p:cNvSpPr>
+            <a:spLocks noGrp="1"/>
+          </p:cNvSpPr>
+          <p:nvPr>
+            <p:ph idx="1"/>
+          </p:nvPr>
+        </p:nvSpPr>
+        <p:spPr/>
+        <p:txBody>
+          <a:bodyPr/>
+          <a:lstStyle/>
+          <a:p>
+            <a:pPr lvl="0" indent="0" marL="0">
+              <a:buNone/>
+            </a:pPr>
+            <a:r>
+              <a:rPr/>
+              <a:t>Documented with full prompts in </a:t>
+            </a:r>
+            <a:r>
+              <a:rPr>
+                <a:latin typeface="Courier"/>
+              </a:rPr>
+              <a:t>LESSON_STEPS.md</a:t>
+            </a:r>
+            <a:r>
+              <a:rPr/>
+              <a:t>:</a:t>
             </a:r>
           </a:p>
           <a:p>
             <a:pPr lvl="0"/>
             <a:r>
-              <a:rPr/>
-              <a:t>A working SQL Server database for your project, populated with realistic test data</a:t>
+              <a:rPr b="1"/>
+              <a:t>8</a:t>
+            </a:r>
+            <a:r>
+              <a:rPr/>
+              <a:t> — Reports (read-only, aggregated, parameterized)</a:t>
             </a:r>
           </a:p>
           <a:p>
             <a:pPr lvl="0"/>
             <a:r>
-              <a:rPr/>
-              <a:t>A C# WinForms project running on your machine</a:t>
+              <a:rPr b="1"/>
+              <a:t>9</a:t>
+            </a:r>
+            <a:r>
+              <a:rPr/>
+              <a:t> — Complex UC flows (orchestrated multi-entity transactions)</a:t>
             </a:r>
           </a:p>
           <a:p>
             <a:pPr lvl="0"/>
             <a:r>
-              <a:rPr/>
-              <a:t>2–3 CRUD screens connected to the database</a:t>
+              <a:rPr b="1"/>
+              <a:t>10</a:t>
+            </a:r>
+            <a:r>
+              <a:rPr/>
+              <a:t> — UI polish (feed Claude screenshots, get richer designs)</a:t>
             </a:r>
           </a:p>
           <a:p>
             <a:pPr lvl="0"/>
             <a:r>
-              <a:rPr/>
-              <a:t>A login screen that routes users by role</a:t>
+              <a:rPr b="1"/>
+              <a:t>11</a:t>
+            </a:r>
+            <a:r>
+              <a:rPr/>
+              <a:t> — Shared DB (BGU central or free Azure SQL)</a:t>
+            </a:r>
+          </a:p>
+          <a:p>
+            <a:pPr lvl="0" indent="0" marL="0">
+              <a:buNone/>
+            </a:pPr>
+            <a:r>
+              <a:rPr/>
+              <a:t>Same pattern as in-class phases. You have the tools.</a:t>
+            </a:r>
+          </a:p>
+        </p:txBody>
+      </p:sp>
+    </p:spTree>
+  </p:cSld>
+</p:sld>
+</file>
+
+<file path=ppt/slides/slide22.xml><?xml version="1.0" encoding="utf-8"?>
+<p:sld xmlns:a="http://schemas.openxmlformats.org/drawingml/2006/main" xmlns:r="http://schemas.openxmlformats.org/officeDocument/2006/relationships" xmlns:p="http://schemas.openxmlformats.org/presentationml/2006/main">
+  <p:cSld>
+    <p:spTree>
+      <p:nvGrpSpPr>
+        <p:cNvPr id="1" name=""/>
+        <p:cNvGrpSpPr/>
+        <p:nvPr/>
+      </p:nvGrpSpPr>
+      <p:grpSpPr>
+        <a:xfrm>
+          <a:off x="0" y="0"/>
+          <a:ext cx="0" cy="0"/>
+          <a:chOff x="0" y="0"/>
+          <a:chExt cx="0" cy="0"/>
+        </a:xfrm>
+      </p:grpSpPr>
+      <p:sp>
+        <p:nvSpPr>
+          <p:cNvPr id="2" name="Title 1"/>
+          <p:cNvSpPr>
+            <a:spLocks noGrp="1"/>
+          </p:cNvSpPr>
+          <p:nvPr>
+            <p:ph type="title"/>
+          </p:nvPr>
+        </p:nvSpPr>
+        <p:spPr/>
+        <p:txBody>
+          <a:bodyPr/>
+          <a:lstStyle/>
+          <a:p>
+            <a:pPr lvl="0" indent="0" marL="0">
+              <a:buNone/>
+            </a:pPr>
+            <a:r>
+              <a:rPr/>
+              <a:t>Review Discipline — Catch Now</a:t>
+            </a:r>
+          </a:p>
+        </p:txBody>
+      </p:sp>
+      <p:sp>
+        <p:nvSpPr>
+          <p:cNvPr id="3" name="Content Placeholder 2"/>
+          <p:cNvSpPr>
+            <a:spLocks noGrp="1"/>
+          </p:cNvSpPr>
+          <p:nvPr>
+            <p:ph idx="1"/>
+          </p:nvPr>
+        </p:nvSpPr>
+        <p:spPr/>
+        <p:txBody>
+          <a:bodyPr/>
+          <a:lstStyle/>
+          <a:p>
+            <a:pPr lvl="0" indent="0" marL="0">
+              <a:buNone/>
+            </a:pPr>
+            <a:r>
+              <a:rPr/>
+              <a:t>Errors that </a:t>
+            </a:r>
+            <a:r>
+              <a:rPr b="1"/>
+              <a:t>won’t</a:t>
+            </a:r>
+            <a:r>
+              <a:rPr/>
+              <a:t> surface later:</a:t>
             </a:r>
           </a:p>
           <a:p>
             <a:pPr lvl="0"/>
             <a:r>
               <a:rPr/>
-              <a:t>Everything driven from Claude Code, end to end</a:t>
-            </a:r>
-          </a:p>
+              <a:t>Implementation scope</a:t>
+            </a:r>
+          </a:p>
+          <a:p>
+            <a:pPr lvl="0"/>
+            <a:r>
+              <a:rPr/>
+              <a:t>Load order / FK ordering</a:t>
+            </a:r>
+          </a:p>
+          <a:p>
+            <a:pPr lvl="0"/>
+            <a:r>
+              <a:rPr/>
+              <a:t>Group decisions</a:t>
+            </a:r>
+          </a:p>
+          <a:p>
+            <a:pPr lvl="0"/>
+            <a:r>
+              <a:rPr/>
+              <a:t>Counts and lists</a:t>
+            </a:r>
+          </a:p>
+          <a:p>
+            <a:pPr lvl="0"/>
+            <a:r>
+              <a:rPr/>
+              <a:t>Silent doc conflicts</a:t>
+            </a:r>
+          </a:p>
+        </p:txBody>
+      </p:sp>
+    </p:spTree>
+  </p:cSld>
+</p:sld>
+</file>
+
+<file path=ppt/slides/slide23.xml><?xml version="1.0" encoding="utf-8"?>
+<p:sld xmlns:a="http://schemas.openxmlformats.org/drawingml/2006/main" xmlns:r="http://schemas.openxmlformats.org/officeDocument/2006/relationships" xmlns:p="http://schemas.openxmlformats.org/presentationml/2006/main">
+  <p:cSld>
+    <p:spTree>
+      <p:nvGrpSpPr>
+        <p:cNvPr id="1" name=""/>
+        <p:cNvGrpSpPr/>
+        <p:nvPr/>
+      </p:nvGrpSpPr>
+      <p:grpSpPr>
+        <a:xfrm>
+          <a:off x="0" y="0"/>
+          <a:ext cx="0" cy="0"/>
+          <a:chOff x="0" y="0"/>
+          <a:chExt cx="0" cy="0"/>
+        </a:xfrm>
+      </p:grpSpPr>
+      <p:sp>
+        <p:nvSpPr>
+          <p:cNvPr id="2" name="Title 1"/>
+          <p:cNvSpPr>
+            <a:spLocks noGrp="1"/>
+          </p:cNvSpPr>
+          <p:nvPr>
+            <p:ph type="title"/>
+          </p:nvPr>
+        </p:nvSpPr>
+        <p:spPr/>
+        <p:txBody>
+          <a:bodyPr/>
+          <a:lstStyle/>
           <a:p>
             <a:pPr lvl="0" indent="0" marL="0">
               <a:buNone/>
             </a:pPr>
             <a:r>
               <a:rPr/>
-              <a:t>You bring: your group’s Part A + Part B analysis, a laptop with the prerequisites installed.</a:t>
+              <a:t>Review Discipline — Don’t Bother</a:t>
+            </a:r>
+          </a:p>
+        </p:txBody>
+      </p:sp>
+      <p:sp>
+        <p:nvSpPr>
+          <p:cNvPr id="3" name="Content Placeholder 2"/>
+          <p:cNvSpPr>
+            <a:spLocks noGrp="1"/>
+          </p:cNvSpPr>
+          <p:nvPr>
+            <p:ph idx="1"/>
+          </p:nvPr>
+        </p:nvSpPr>
+        <p:spPr/>
+        <p:txBody>
+          <a:bodyPr/>
+          <a:lstStyle/>
+          <a:p>
+            <a:pPr lvl="0" indent="0" marL="0">
+              <a:buNone/>
+            </a:pPr>
+            <a:r>
+              <a:rPr/>
+              <a:t>Errors the compiler catches the moment code references them:</a:t>
+            </a:r>
+          </a:p>
+          <a:p>
+            <a:pPr lvl="0"/>
+            <a:r>
+              <a:rPr/>
+              <a:t>Attribute names</a:t>
+            </a:r>
+          </a:p>
+          <a:p>
+            <a:pPr lvl="0"/>
+            <a:r>
+              <a:rPr/>
+              <a:t>Enum values</a:t>
+            </a:r>
+          </a:p>
+          <a:p>
+            <a:pPr lvl="0"/>
+            <a:r>
+              <a:rPr/>
+              <a:t>Method signatures</a:t>
+            </a:r>
+          </a:p>
+          <a:p>
+            <a:pPr lvl="0"/>
+            <a:r>
+              <a:rPr/>
+              <a:t>Minor wording</a:t>
+            </a:r>
+          </a:p>
+          <a:p>
+            <a:pPr lvl="0" indent="0" marL="0">
+              <a:buNone/>
+            </a:pPr>
+            <a:r>
+              <a:rPr/>
+              <a:t>Save your attention for the silent ones.</a:t>
+            </a:r>
+          </a:p>
+        </p:txBody>
+      </p:sp>
+    </p:spTree>
+  </p:cSld>
+</p:sld>
+</file>
+
+<file path=ppt/slides/slide24.xml><?xml version="1.0" encoding="utf-8"?>
+<p:sld xmlns:a="http://schemas.openxmlformats.org/drawingml/2006/main" xmlns:r="http://schemas.openxmlformats.org/officeDocument/2006/relationships" xmlns:p="http://schemas.openxmlformats.org/presentationml/2006/main">
+  <p:cSld>
+    <p:spTree>
+      <p:nvGrpSpPr>
+        <p:cNvPr id="1" name=""/>
+        <p:cNvGrpSpPr/>
+        <p:nvPr/>
+      </p:nvGrpSpPr>
+      <p:grpSpPr>
+        <a:xfrm>
+          <a:off x="0" y="0"/>
+          <a:ext cx="0" cy="0"/>
+          <a:chOff x="0" y="0"/>
+          <a:chExt cx="0" cy="0"/>
+        </a:xfrm>
+      </p:grpSpPr>
+      <p:sp>
+        <p:nvSpPr>
+          <p:cNvPr id="2" name="Title 1"/>
+          <p:cNvSpPr>
+            <a:spLocks noGrp="1"/>
+          </p:cNvSpPr>
+          <p:nvPr>
+            <p:ph type="title"/>
+          </p:nvPr>
+        </p:nvSpPr>
+        <p:spPr/>
+        <p:txBody>
+          <a:bodyPr/>
+          <a:lstStyle/>
+          <a:p>
+            <a:pPr lvl="0" indent="0" marL="0">
+              <a:buNone/>
+            </a:pPr>
+            <a:r>
+              <a:rPr/>
+              <a:t>Working With Claude</a:t>
+            </a:r>
+          </a:p>
+        </p:txBody>
+      </p:sp>
+      <p:sp>
+        <p:nvSpPr>
+          <p:cNvPr id="3" name="Content Placeholder 2"/>
+          <p:cNvSpPr>
+            <a:spLocks noGrp="1"/>
+          </p:cNvSpPr>
+          <p:nvPr>
+            <p:ph idx="1"/>
+          </p:nvPr>
+        </p:nvSpPr>
+        <p:spPr/>
+        <p:txBody>
+          <a:bodyPr/>
+          <a:lstStyle/>
+          <a:p>
+            <a:pPr lvl="0"/>
+            <a:r>
+              <a:rPr b="1"/>
+              <a:t>Always ask Claude first.</a:t>
+            </a:r>
+            <a:r>
+              <a:rPr/>
+              <a:t> Let it do the work, you review.</a:t>
+            </a:r>
+          </a:p>
+          <a:p>
+            <a:pPr lvl="0"/>
+            <a:r>
+              <a:rPr b="1"/>
+              <a:t>Push back specifically.</a:t>
+            </a:r>
+            <a:r>
+              <a:rPr/>
+              <a:t> Cite source, page, count.</a:t>
+            </a:r>
+          </a:p>
+          <a:p>
+            <a:pPr lvl="0"/>
+            <a:r>
+              <a:rPr b="1"/>
+              <a:t>Persist decisions in files.</a:t>
+            </a:r>
+            <a:r>
+              <a:rPr/>
+              <a:t> </a:t>
+            </a:r>
+            <a:r>
+              <a:rPr>
+                <a:latin typeface="Courier"/>
+              </a:rPr>
+              <a:t>CLAUDE.md</a:t>
+            </a:r>
+            <a:r>
+              <a:rPr/>
+              <a:t> carries forward to every session.</a:t>
+            </a:r>
+          </a:p>
+          <a:p>
+            <a:pPr lvl="0"/>
+            <a:r>
+              <a:rPr b="1"/>
+              <a:t>One prompt per concern.</a:t>
+            </a:r>
+            <a:r>
+              <a:rPr/>
+              <a:t> Don’t combine “generate, change, deploy” in one prompt.</a:t>
+            </a:r>
+          </a:p>
+          <a:p>
+            <a:pPr lvl="0"/>
+            <a:r>
+              <a:rPr b="1"/>
+              <a:t>Never commit </a:t>
+            </a:r>
+            <a:r>
+              <a:rPr b="1">
+                <a:latin typeface="Courier"/>
+              </a:rPr>
+              <a:t>.mcp.json</a:t>
+            </a:r>
+            <a:r>
+              <a:rPr b="1"/>
+              <a:t> or </a:t>
+            </a:r>
+            <a:r>
+              <a:rPr b="1">
+                <a:latin typeface="Courier"/>
+              </a:rPr>
+              <a:t>app.config</a:t>
+            </a:r>
+            <a:r>
+              <a:rPr b="1"/>
+              <a:t>.</a:t>
+            </a:r>
+            <a:r>
+              <a:rPr/>
+              <a:t> Credentials.</a:t>
+            </a:r>
+          </a:p>
+        </p:txBody>
+      </p:sp>
+    </p:spTree>
+  </p:cSld>
+</p:sld>
+</file>
+
+<file path=ppt/slides/slide25.xml><?xml version="1.0" encoding="utf-8"?>
+<p:sld xmlns:a="http://schemas.openxmlformats.org/drawingml/2006/main" xmlns:r="http://schemas.openxmlformats.org/officeDocument/2006/relationships" xmlns:p="http://schemas.openxmlformats.org/presentationml/2006/main">
+  <p:cSld>
+    <p:spTree>
+      <p:nvGrpSpPr>
+        <p:cNvPr id="1" name=""/>
+        <p:cNvGrpSpPr/>
+        <p:nvPr/>
+      </p:nvGrpSpPr>
+      <p:grpSpPr>
+        <a:xfrm>
+          <a:off x="0" y="0"/>
+          <a:ext cx="0" cy="0"/>
+          <a:chOff x="0" y="0"/>
+          <a:chExt cx="0" cy="0"/>
+        </a:xfrm>
+      </p:grpSpPr>
+      <p:sp>
+        <p:nvSpPr>
+          <p:cNvPr id="2" name="Title 1"/>
+          <p:cNvSpPr>
+            <a:spLocks noGrp="1"/>
+          </p:cNvSpPr>
+          <p:nvPr>
+            <p:ph type="title"/>
+          </p:nvPr>
+        </p:nvSpPr>
+        <p:spPr/>
+        <p:txBody>
+          <a:bodyPr/>
+          <a:lstStyle/>
+          <a:p>
+            <a:pPr lvl="0" indent="0" marL="0">
+              <a:buNone/>
+            </a:pPr>
+            <a:r>
+              <a:rPr/>
+              <a:t>Take-Home Materials</a:t>
+            </a:r>
+          </a:p>
+        </p:txBody>
+      </p:sp>
+      <p:sp>
+        <p:nvSpPr>
+          <p:cNvPr id="3" name="Content Placeholder 2"/>
+          <p:cNvSpPr>
+            <a:spLocks noGrp="1"/>
+          </p:cNvSpPr>
+          <p:nvPr>
+            <p:ph idx="1"/>
+          </p:nvPr>
+        </p:nvSpPr>
+        <p:spPr/>
+        <p:txBody>
+          <a:bodyPr/>
+          <a:lstStyle/>
+          <a:p>
+            <a:pPr lvl="0"/>
+            <a:r>
+              <a:rPr b="1">
+                <a:latin typeface="Courier"/>
+              </a:rPr>
+              <a:t>PREREQS.md</a:t>
+            </a:r>
+            <a:r>
+              <a:rPr/>
+              <a:t> — install once</a:t>
+            </a:r>
+          </a:p>
+          <a:p>
+            <a:pPr lvl="0"/>
+            <a:r>
+              <a:rPr b="1">
+                <a:latin typeface="Courier"/>
+              </a:rPr>
+              <a:t>LESSON_STEPS.md</a:t>
+            </a:r>
+            <a:r>
+              <a:rPr/>
+              <a:t> — full reference with rationale</a:t>
+            </a:r>
+          </a:p>
+          <a:p>
+            <a:pPr lvl="0"/>
+            <a:r>
+              <a:rPr b="1">
+                <a:latin typeface="Courier"/>
+              </a:rPr>
+              <a:t>PROMPTS_CHEATSHEET.md</a:t>
+            </a:r>
+            <a:r>
+              <a:rPr/>
+              <a:t> — every prompt in copy-paste form</a:t>
+            </a:r>
+          </a:p>
+          <a:p>
+            <a:pPr lvl="0"/>
+            <a:r>
+              <a:rPr b="1"/>
+              <a:t>Your group’s repo</a:t>
+            </a:r>
+            <a:r>
+              <a:rPr/>
+              <a:t> — working scaffold, CLAUDE.md, runnable panel</a:t>
+            </a:r>
+          </a:p>
+          <a:p>
+            <a:pPr lvl="0" indent="0" marL="0">
+              <a:buNone/>
+            </a:pPr>
+            <a:r>
+              <a:rPr/>
+              <a:t>After class: pick up where you stopped, then 8–11 over the semester.</a:t>
+            </a:r>
+          </a:p>
+        </p:txBody>
+      </p:sp>
+    </p:spTree>
+  </p:cSld>
+</p:sld>
+</file>
+
+<file path=ppt/slides/slide26.xml><?xml version="1.0" encoding="utf-8"?>
+<p:sld xmlns:a="http://schemas.openxmlformats.org/drawingml/2006/main" xmlns:r="http://schemas.openxmlformats.org/officeDocument/2006/relationships" xmlns:p="http://schemas.openxmlformats.org/presentationml/2006/main">
+  <p:cSld>
+    <p:spTree>
+      <p:nvGrpSpPr>
+        <p:cNvPr id="1" name=""/>
+        <p:cNvGrpSpPr/>
+        <p:nvPr/>
+      </p:nvGrpSpPr>
+      <p:grpSpPr>
+        <a:xfrm>
+          <a:off x="0" y="0"/>
+          <a:ext cx="0" cy="0"/>
+          <a:chOff x="0" y="0"/>
+          <a:chExt cx="0" cy="0"/>
+        </a:xfrm>
+      </p:grpSpPr>
+      <p:sp>
+        <p:nvSpPr>
+          <p:cNvPr id="2" name="Title 1"/>
+          <p:cNvSpPr>
+            <a:spLocks noGrp="1"/>
+          </p:cNvSpPr>
+          <p:nvPr>
+            <p:ph type="title"/>
+          </p:nvPr>
+        </p:nvSpPr>
+        <p:spPr/>
+        <p:txBody>
+          <a:bodyPr/>
+          <a:lstStyle/>
+          <a:p>
+            <a:pPr lvl="0" indent="0" marL="0">
+              <a:buNone/>
+            </a:pPr>
+            <a:r>
+              <a:rPr/>
+              <a:t>Questions</a:t>
+            </a:r>
+          </a:p>
+        </p:txBody>
+      </p:sp>
+      <p:sp>
+        <p:nvSpPr>
+          <p:cNvPr id="3" name="Content Placeholder 2"/>
+          <p:cNvSpPr>
+            <a:spLocks noGrp="1"/>
+          </p:cNvSpPr>
+          <p:nvPr>
+            <p:ph idx="1"/>
+          </p:nvPr>
+        </p:nvSpPr>
+        <p:spPr/>
+        <p:txBody>
+          <a:bodyPr/>
+          <a:lstStyle/>
+          <a:p>
+            <a:pPr lvl="0" indent="0" marL="0">
+              <a:buNone/>
+            </a:pPr>
+            <a:r>
+              <a:rPr/>
+              <a:t>Repo: github.com/dcodish/SAD-sample-project</a:t>
+            </a:r>
+          </a:p>
+          <a:p>
+            <a:pPr lvl="0" indent="0" marL="0">
+              <a:buNone/>
+            </a:pPr>
+            <a:r>
+              <a:rPr/>
+              <a:t>When stuck:</a:t>
+            </a:r>
+          </a:p>
+          <a:p>
+            <a:pPr lvl="0" indent="-342900" marL="342900">
+              <a:buAutoNum type="arabicPeriod"/>
+            </a:pPr>
+            <a:r>
+              <a:rPr/>
+              <a:t>Paste the error into Claude Code — full context</a:t>
+            </a:r>
+          </a:p>
+          <a:p>
+            <a:pPr lvl="0" indent="-342900" marL="342900">
+              <a:buAutoNum type="arabicPeriod"/>
+            </a:pPr>
+            <a:r>
+              <a:rPr/>
+              <a:t>Course group chat — second line</a:t>
+            </a:r>
+          </a:p>
+          <a:p>
+            <a:pPr lvl="0" indent="-342900" marL="342900">
+              <a:buAutoNum type="arabicPeriod"/>
+            </a:pPr>
+            <a:r>
+              <a:rPr/>
+              <a:t>Office hours — last resort</a:t>
             </a:r>
           </a:p>
         </p:txBody>
@@ -4644,7 +5402,91 @@
             </a:pPr>
             <a:r>
               <a:rPr/>
-              <a:t>The Big Picture</a:t>
+              <a:t>What You Bring</a:t>
+            </a:r>
+          </a:p>
+        </p:txBody>
+      </p:sp>
+      <p:sp>
+        <p:nvSpPr>
+          <p:cNvPr id="3" name="Content Placeholder 2"/>
+          <p:cNvSpPr>
+            <a:spLocks noGrp="1"/>
+          </p:cNvSpPr>
+          <p:nvPr>
+            <p:ph idx="1"/>
+          </p:nvPr>
+        </p:nvSpPr>
+        <p:spPr/>
+        <p:txBody>
+          <a:bodyPr/>
+          <a:lstStyle/>
+          <a:p>
+            <a:pPr lvl="0"/>
+            <a:r>
+              <a:rPr/>
+              <a:t>Your group’s Part A + Part B analysis</a:t>
+            </a:r>
+          </a:p>
+          <a:p>
+            <a:pPr lvl="0"/>
+            <a:r>
+              <a:rPr/>
+              <a:t>A laptop with all prerequisites installed</a:t>
+            </a:r>
+          </a:p>
+          <a:p>
+            <a:pPr lvl="0"/>
+            <a:r>
+              <a:rPr/>
+              <a:t>Your group’s project folder, ready to go</a:t>
+            </a:r>
+          </a:p>
+        </p:txBody>
+      </p:sp>
+    </p:spTree>
+  </p:cSld>
+</p:sld>
+</file>
+
+<file path=ppt/slides/slide4.xml><?xml version="1.0" encoding="utf-8"?>
+<p:sld xmlns:a="http://schemas.openxmlformats.org/drawingml/2006/main" xmlns:r="http://schemas.openxmlformats.org/officeDocument/2006/relationships" xmlns:p="http://schemas.openxmlformats.org/presentationml/2006/main">
+  <p:cSld>
+    <p:spTree>
+      <p:nvGrpSpPr>
+        <p:cNvPr id="1" name=""/>
+        <p:cNvGrpSpPr/>
+        <p:nvPr/>
+      </p:nvGrpSpPr>
+      <p:grpSpPr>
+        <a:xfrm>
+          <a:off x="0" y="0"/>
+          <a:ext cx="0" cy="0"/>
+          <a:chOff x="0" y="0"/>
+          <a:chExt cx="0" cy="0"/>
+        </a:xfrm>
+      </p:grpSpPr>
+      <p:sp>
+        <p:nvSpPr>
+          <p:cNvPr id="2" name="Title 1"/>
+          <p:cNvSpPr>
+            <a:spLocks noGrp="1"/>
+          </p:cNvSpPr>
+          <p:nvPr>
+            <p:ph type="title"/>
+          </p:nvPr>
+        </p:nvSpPr>
+        <p:spPr/>
+        <p:txBody>
+          <a:bodyPr/>
+          <a:lstStyle/>
+          <a:p>
+            <a:pPr lvl="0" indent="0" marL="0">
+              <a:buNone/>
+            </a:pPr>
+            <a:r>
+              <a:rPr/>
+              <a:t>The Big Picture — In Class</a:t>
             </a:r>
           </a:p>
         </p:txBody>
@@ -4670,9 +5512,8 @@
                 <a:tableStyleId>{5C22544A-7EE6-4342-B048-85BDC9FD1C3A}</a:tableStyleId>
               </a:tblPr>
               <a:tblGrid>
-                <a:gridCol w="2743200"/>
-                <a:gridCol w="2743200"/>
-                <a:gridCol w="2743200"/>
+                <a:gridCol w="4114800"/>
+                <a:gridCol w="4114800"/>
               </a:tblGrid>
               <a:tr h="0">
                 <a:tc>
@@ -4702,22 +5543,6 @@
                       <a:r>
                         <a:rPr/>
                         <a:t>What</a:t>
-                      </a:r>
-                    </a:p>
-                  </a:txBody>
-                  <a:tcPr/>
-                </a:tc>
-                <a:tc>
-                  <a:txBody>
-                    <a:bodyPr/>
-                    <a:lstStyle/>
-                    <a:p>
-                      <a:pPr lvl="0" indent="0" marL="0">
-                        <a:buNone/>
-                      </a:pPr>
-                      <a:r>
-                        <a:rPr/>
-                        <a:t>In class?</a:t>
                       </a:r>
                     </a:p>
                   </a:txBody>
@@ -4755,21 +5580,6 @@
                     </a:p>
                   </a:txBody>
                 </a:tc>
-                <a:tc>
-                  <a:txBody>
-                    <a:bodyPr/>
-                    <a:lstStyle/>
-                    <a:p>
-                      <a:pPr lvl="0" indent="0" marL="0">
-                        <a:buNone/>
-                      </a:pPr>
-                      <a:r>
-                        <a:rPr/>
-                        <a:t>✅</a:t>
-                      </a:r>
-                    </a:p>
-                  </a:txBody>
-                </a:tc>
               </a:tr>
               <a:tr h="0">
                 <a:tc>
@@ -4798,21 +5608,6 @@
                       <a:r>
                         <a:rPr/>
                         <a:t>Extract analysis to markdown</a:t>
-                      </a:r>
-                    </a:p>
-                  </a:txBody>
-                </a:tc>
-                <a:tc>
-                  <a:txBody>
-                    <a:bodyPr/>
-                    <a:lstStyle/>
-                    <a:p>
-                      <a:pPr lvl="0" indent="0" marL="0">
-                        <a:buNone/>
-                      </a:pPr>
-                      <a:r>
-                        <a:rPr/>
-                        <a:t>✅</a:t>
                       </a:r>
                     </a:p>
                   </a:txBody>
@@ -4849,21 +5644,6 @@
                     </a:p>
                   </a:txBody>
                 </a:tc>
-                <a:tc>
-                  <a:txBody>
-                    <a:bodyPr/>
-                    <a:lstStyle/>
-                    <a:p>
-                      <a:pPr lvl="0" indent="0" marL="0">
-                        <a:buNone/>
-                      </a:pPr>
-                      <a:r>
-                        <a:rPr/>
-                        <a:t>✅</a:t>
-                      </a:r>
-                    </a:p>
-                  </a:txBody>
-                </a:tc>
               </a:tr>
               <a:tr h="0">
                 <a:tc>
@@ -4892,21 +5672,6 @@
                       <a:r>
                         <a:rPr/>
                         <a:t>Database schema + stored procedures</a:t>
-                      </a:r>
-                    </a:p>
-                  </a:txBody>
-                </a:tc>
-                <a:tc>
-                  <a:txBody>
-                    <a:bodyPr/>
-                    <a:lstStyle/>
-                    <a:p>
-                      <a:pPr lvl="0" indent="0" marL="0">
-                        <a:buNone/>
-                      </a:pPr>
-                      <a:r>
-                        <a:rPr/>
-                        <a:t>✅</a:t>
                       </a:r>
                     </a:p>
                   </a:txBody>
@@ -4943,21 +5708,6 @@
                     </a:p>
                   </a:txBody>
                 </a:tc>
-                <a:tc>
-                  <a:txBody>
-                    <a:bodyPr/>
-                    <a:lstStyle/>
-                    <a:p>
-                      <a:pPr lvl="0" indent="0" marL="0">
-                        <a:buNone/>
-                      </a:pPr>
-                      <a:r>
-                        <a:rPr/>
-                        <a:t>✅</a:t>
-                      </a:r>
-                    </a:p>
-                  </a:txBody>
-                </a:tc>
               </a:tr>
               <a:tr h="0">
                 <a:tc>
@@ -4986,21 +5736,6 @@
                       <a:r>
                         <a:rPr/>
                         <a:t>C# scaffold + entry flow + first panel</a:t>
-                      </a:r>
-                    </a:p>
-                  </a:txBody>
-                </a:tc>
-                <a:tc>
-                  <a:txBody>
-                    <a:bodyPr/>
-                    <a:lstStyle/>
-                    <a:p>
-                      <a:pPr lvl="0" indent="0" marL="0">
-                        <a:buNone/>
-                      </a:pPr>
-                      <a:r>
-                        <a:rPr/>
-                        <a:t>✅</a:t>
                       </a:r>
                     </a:p>
                   </a:txBody>
@@ -5037,21 +5772,6 @@
                     </a:p>
                   </a:txBody>
                 </a:tc>
-                <a:tc>
-                  <a:txBody>
-                    <a:bodyPr/>
-                    <a:lstStyle/>
-                    <a:p>
-                      <a:pPr lvl="0" indent="0" marL="0">
-                        <a:buNone/>
-                      </a:pPr>
-                      <a:r>
-                        <a:rPr/>
-                        <a:t>✅</a:t>
-                      </a:r>
-                    </a:p>
-                  </a:txBody>
-                </a:tc>
               </a:tr>
               <a:tr h="0">
                 <a:tc>
@@ -5079,69 +5799,7 @@
                       </a:pPr>
                       <a:r>
                         <a:rPr/>
-                        <a:t>State machines</a:t>
-                      </a:r>
-                    </a:p>
-                  </a:txBody>
-                </a:tc>
-                <a:tc>
-                  <a:txBody>
-                    <a:bodyPr/>
-                    <a:lstStyle/>
-                    <a:p>
-                      <a:pPr lvl="0" indent="0" marL="0">
-                        <a:buNone/>
-                      </a:pPr>
-                      <a:r>
-                        <a:rPr/>
-                        <a:t>✅ if time</a:t>
-                      </a:r>
-                    </a:p>
-                  </a:txBody>
-                </a:tc>
-              </a:tr>
-              <a:tr h="0">
-                <a:tc>
-                  <a:txBody>
-                    <a:bodyPr/>
-                    <a:lstStyle/>
-                    <a:p>
-                      <a:pPr lvl="0" indent="0" marL="0">
-                        <a:buNone/>
-                      </a:pPr>
-                      <a:r>
-                        <a:rPr/>
-                        <a:t>8–11</a:t>
-                      </a:r>
-                    </a:p>
-                  </a:txBody>
-                </a:tc>
-                <a:tc>
-                  <a:txBody>
-                    <a:bodyPr/>
-                    <a:lstStyle/>
-                    <a:p>
-                      <a:pPr lvl="0" indent="0" marL="0">
-                        <a:buNone/>
-                      </a:pPr>
-                      <a:r>
-                        <a:rPr/>
-                        <a:t>Reports, complex flows, UI polish, shared DB</a:t>
-                      </a:r>
-                    </a:p>
-                  </a:txBody>
-                </a:tc>
-                <a:tc>
-                  <a:txBody>
-                    <a:bodyPr/>
-                    <a:lstStyle/>
-                    <a:p>
-                      <a:pPr lvl="0" indent="0" marL="0">
-                        <a:buNone/>
-                      </a:pPr>
-                      <a:r>
-                        <a:rPr/>
-                        <a:t>Homework</a:t>
+                        <a:t>State machines (if time)</a:t>
                       </a:r>
                     </a:p>
                   </a:txBody>
@@ -5151,118 +5809,6 @@
           </a:graphicData>
         </a:graphic>
       </p:graphicFrame>
-    </p:spTree>
-  </p:cSld>
-</p:sld>
-</file>
-
-<file path=ppt/slides/slide4.xml><?xml version="1.0" encoding="utf-8"?>
-<p:sld xmlns:a="http://schemas.openxmlformats.org/drawingml/2006/main" xmlns:r="http://schemas.openxmlformats.org/officeDocument/2006/relationships" xmlns:p="http://schemas.openxmlformats.org/presentationml/2006/main">
-  <p:cSld>
-    <p:spTree>
-      <p:nvGrpSpPr>
-        <p:cNvPr id="1" name=""/>
-        <p:cNvGrpSpPr/>
-        <p:nvPr/>
-      </p:nvGrpSpPr>
-      <p:grpSpPr>
-        <a:xfrm>
-          <a:off x="0" y="0"/>
-          <a:ext cx="0" cy="0"/>
-          <a:chOff x="0" y="0"/>
-          <a:chExt cx="0" cy="0"/>
-        </a:xfrm>
-      </p:grpSpPr>
-      <p:sp>
-        <p:nvSpPr>
-          <p:cNvPr id="2" name="Title 1"/>
-          <p:cNvSpPr>
-            <a:spLocks noGrp="1"/>
-          </p:cNvSpPr>
-          <p:nvPr>
-            <p:ph type="title"/>
-          </p:nvPr>
-        </p:nvSpPr>
-        <p:spPr/>
-        <p:txBody>
-          <a:bodyPr/>
-          <a:lstStyle/>
-          <a:p>
-            <a:pPr lvl="0" indent="0" marL="0">
-              <a:buNone/>
-            </a:pPr>
-            <a:r>
-              <a:rPr/>
-              <a:t>Three Things Drive This Lesson</a:t>
-            </a:r>
-          </a:p>
-        </p:txBody>
-      </p:sp>
-      <p:sp>
-        <p:nvSpPr>
-          <p:cNvPr id="3" name="Content Placeholder 2"/>
-          <p:cNvSpPr>
-            <a:spLocks noGrp="1"/>
-          </p:cNvSpPr>
-          <p:nvPr>
-            <p:ph idx="1"/>
-          </p:nvPr>
-        </p:nvSpPr>
-        <p:spPr/>
-        <p:txBody>
-          <a:bodyPr/>
-          <a:lstStyle/>
-          <a:p>
-            <a:pPr lvl="0" indent="0" marL="0">
-              <a:buNone/>
-            </a:pPr>
-            <a:r>
-              <a:rPr b="1"/>
-              <a:t>1. Stay in Claude Code.</a:t>
-            </a:r>
-            <a:r>
-              <a:rPr/>
-              <a:t> Almost everything goes through one tool — file edits, SQL, builds, tests. No bouncing between SSMS, terminal, browser.</a:t>
-            </a:r>
-          </a:p>
-          <a:p>
-            <a:pPr lvl="0" indent="0" marL="0">
-              <a:buNone/>
-            </a:pPr>
-            <a:r>
-              <a:rPr b="1"/>
-              <a:t>2. Markdown and </a:t>
-            </a:r>
-            <a:r>
-              <a:rPr b="1">
-                <a:latin typeface="Courier"/>
-              </a:rPr>
-              <a:t>.sql</a:t>
-            </a:r>
-            <a:r>
-              <a:rPr b="1"/>
-              <a:t> files are the source of truth.</a:t>
-            </a:r>
-            <a:r>
-              <a:rPr/>
-              <a:t> The database is just a cached projection of your scripts. If it’s not in a file in git, it doesn’t durably exist.</a:t>
-            </a:r>
-          </a:p>
-          <a:p>
-            <a:pPr lvl="0" indent="0" marL="0">
-              <a:buNone/>
-            </a:pPr>
-            <a:r>
-              <a:rPr b="1"/>
-              <a:t>3. Review what Claude produces.</a:t>
-            </a:r>
-            <a:r>
-              <a:rPr/>
-              <a:t> Claude is fast but not careful. Skipping review now means debugging silent errors for the rest of the semester.</a:t>
-            </a:r>
-          </a:p>
-        </p:txBody>
-      </p:sp>
     </p:spTree>
   </p:cSld>
 </p:sld>
@@ -5305,165 +5851,201 @@
             </a:pPr>
             <a:r>
               <a:rPr/>
-              <a:t>Prerequisites — Done Before Class</a:t>
-            </a:r>
-          </a:p>
-        </p:txBody>
-      </p:sp>
-      <p:sp>
-        <p:nvSpPr>
-          <p:cNvPr id="3" name="Content Placeholder 2"/>
-          <p:cNvSpPr>
-            <a:spLocks noGrp="1"/>
-          </p:cNvSpPr>
+              <a:t>The Big Picture — Homework</a:t>
+            </a:r>
+          </a:p>
+        </p:txBody>
+      </p:sp>
+      <p:graphicFrame>
+        <p:nvGraphicFramePr>
+          <p:cNvPr id="6" name="Content Placeholder 5"/>
+          <p:cNvGraphicFramePr>
+            <a:graphicFrameLocks noGrp="1"/>
+          </p:cNvGraphicFramePr>
           <p:nvPr>
             <p:ph idx="1"/>
           </p:nvPr>
-        </p:nvSpPr>
-        <p:spPr/>
-        <p:txBody>
-          <a:bodyPr/>
-          <a:lstStyle/>
-          <a:p>
-            <a:pPr lvl="0" indent="0" marL="0">
-              <a:buNone/>
-            </a:pPr>
-            <a:r>
-              <a:rPr/>
-              <a:t>If these don’t all succeed in a fresh terminal, you’re not ready:</a:t>
-            </a:r>
-          </a:p>
-          <a:p>
-            <a:pPr lvl="0" indent="0">
-              <a:buNone/>
-            </a:pPr>
-            <a:r>
-              <a:rPr>
-                <a:latin typeface="Courier"/>
-              </a:rPr>
-              <a:t>dotnet </a:t>
-            </a:r>
-            <a:r>
-              <a:rPr>
-                <a:solidFill>
-                  <a:srgbClr val="666666"/>
-                </a:solidFill>
-                <a:latin typeface="Courier"/>
-              </a:rPr>
-              <a:t>--</a:t>
-            </a:r>
-            <a:r>
-              <a:rPr>
-                <a:latin typeface="Courier"/>
-              </a:rPr>
-              <a:t>version       </a:t>
-            </a:r>
-            <a:r>
-              <a:rPr i="1">
-                <a:solidFill>
-                  <a:srgbClr val="60A0B0"/>
-                </a:solidFill>
-                <a:latin typeface="Courier"/>
-              </a:rPr>
-              <a:t># 8.x</a:t>
-            </a:r>
-            <a:br/>
-            <a:r>
-              <a:rPr>
-                <a:latin typeface="Courier"/>
-              </a:rPr>
-              <a:t>git </a:t>
-            </a:r>
-            <a:r>
-              <a:rPr>
-                <a:solidFill>
-                  <a:srgbClr val="666666"/>
-                </a:solidFill>
-                <a:latin typeface="Courier"/>
-              </a:rPr>
-              <a:t>--</a:t>
-            </a:r>
-            <a:r>
-              <a:rPr>
-                <a:latin typeface="Courier"/>
-              </a:rPr>
-              <a:t>version</a:t>
-            </a:r>
-            <a:br/>
-            <a:r>
-              <a:rPr>
-                <a:latin typeface="Courier"/>
-              </a:rPr>
-              <a:t>uvx </a:t>
-            </a:r>
-            <a:r>
-              <a:rPr>
-                <a:solidFill>
-                  <a:srgbClr val="666666"/>
-                </a:solidFill>
-                <a:latin typeface="Courier"/>
-              </a:rPr>
-              <a:t>--</a:t>
-            </a:r>
-            <a:r>
-              <a:rPr>
-                <a:latin typeface="Courier"/>
-              </a:rPr>
-              <a:t>version</a:t>
-            </a:r>
-            <a:br/>
-            <a:r>
-              <a:rPr>
-                <a:latin typeface="Courier"/>
-              </a:rPr>
-              <a:t>sqlcmd </a:t>
-            </a:r>
-            <a:r>
-              <a:rPr>
-                <a:solidFill>
-                  <a:srgbClr val="666666"/>
-                </a:solidFill>
-                <a:latin typeface="Courier"/>
-              </a:rPr>
-              <a:t>-</a:t>
-            </a:r>
-            <a:r>
-              <a:rPr>
-                <a:latin typeface="Courier"/>
-              </a:rPr>
-              <a:t>L</a:t>
-            </a:r>
-          </a:p>
-          <a:p>
-            <a:pPr lvl="0" indent="0" marL="0">
-              <a:buNone/>
-            </a:pPr>
-            <a:r>
-              <a:rPr/>
-              <a:t>Plus: Claude Code extension signed in (Pro/Max subscription), VS 2025 open, SSMS connects to local SQL Server.</a:t>
-            </a:r>
-          </a:p>
-          <a:p>
-            <a:pPr lvl="0" indent="0" marL="0">
-              <a:buNone/>
-            </a:pPr>
-            <a:r>
-              <a:rPr/>
-              <a:t>Full details in </a:t>
-            </a:r>
-            <a:r>
-              <a:rPr b="1">
-                <a:latin typeface="Courier"/>
-              </a:rPr>
-              <a:t>PREREQS.md</a:t>
-            </a:r>
-            <a:r>
-              <a:rPr/>
-              <a:t>.</a:t>
-            </a:r>
-          </a:p>
-        </p:txBody>
-      </p:sp>
+        </p:nvGraphicFramePr>
+        <p:xfrm>
+          <a:off x="457200" y="1193800"/>
+          <a:ext cx="8229600" cy="3390900"/>
+        </p:xfrm>
+        <a:graphic>
+          <a:graphicData uri="http://schemas.openxmlformats.org/drawingml/2006/table">
+            <a:tbl>
+              <a:tblPr firstRow="1" bandRow="1">
+                <a:tableStyleId>{5C22544A-7EE6-4342-B048-85BDC9FD1C3A}</a:tableStyleId>
+              </a:tblPr>
+              <a:tblGrid>
+                <a:gridCol w="4114800"/>
+                <a:gridCol w="4114800"/>
+              </a:tblGrid>
+              <a:tr h="0">
+                <a:tc>
+                  <a:txBody>
+                    <a:bodyPr/>
+                    <a:lstStyle/>
+                    <a:p>
+                      <a:pPr lvl="0" indent="0" marL="0">
+                        <a:buNone/>
+                      </a:pPr>
+                      <a:r>
+                        <a:rPr/>
+                        <a:t>Phase</a:t>
+                      </a:r>
+                    </a:p>
+                  </a:txBody>
+                  <a:tcPr/>
+                </a:tc>
+                <a:tc>
+                  <a:txBody>
+                    <a:bodyPr/>
+                    <a:lstStyle/>
+                    <a:p>
+                      <a:pPr lvl="0" indent="0" marL="0">
+                        <a:buNone/>
+                      </a:pPr>
+                      <a:r>
+                        <a:rPr/>
+                        <a:t>What</a:t>
+                      </a:r>
+                    </a:p>
+                  </a:txBody>
+                  <a:tcPr/>
+                </a:tc>
+              </a:tr>
+              <a:tr h="0">
+                <a:tc>
+                  <a:txBody>
+                    <a:bodyPr/>
+                    <a:lstStyle/>
+                    <a:p>
+                      <a:pPr lvl="0" indent="0" marL="0">
+                        <a:buNone/>
+                      </a:pPr>
+                      <a:r>
+                        <a:rPr/>
+                        <a:t>8</a:t>
+                      </a:r>
+                    </a:p>
+                  </a:txBody>
+                </a:tc>
+                <a:tc>
+                  <a:txBody>
+                    <a:bodyPr/>
+                    <a:lstStyle/>
+                    <a:p>
+                      <a:pPr lvl="0" indent="0" marL="0">
+                        <a:buNone/>
+                      </a:pPr>
+                      <a:r>
+                        <a:rPr/>
+                        <a:t>Reports</a:t>
+                      </a:r>
+                    </a:p>
+                  </a:txBody>
+                </a:tc>
+              </a:tr>
+              <a:tr h="0">
+                <a:tc>
+                  <a:txBody>
+                    <a:bodyPr/>
+                    <a:lstStyle/>
+                    <a:p>
+                      <a:pPr lvl="0" indent="0" marL="0">
+                        <a:buNone/>
+                      </a:pPr>
+                      <a:r>
+                        <a:rPr/>
+                        <a:t>9</a:t>
+                      </a:r>
+                    </a:p>
+                  </a:txBody>
+                </a:tc>
+                <a:tc>
+                  <a:txBody>
+                    <a:bodyPr/>
+                    <a:lstStyle/>
+                    <a:p>
+                      <a:pPr lvl="0" indent="0" marL="0">
+                        <a:buNone/>
+                      </a:pPr>
+                      <a:r>
+                        <a:rPr/>
+                        <a:t>Complex UC flows</a:t>
+                      </a:r>
+                    </a:p>
+                  </a:txBody>
+                </a:tc>
+              </a:tr>
+              <a:tr h="0">
+                <a:tc>
+                  <a:txBody>
+                    <a:bodyPr/>
+                    <a:lstStyle/>
+                    <a:p>
+                      <a:pPr lvl="0" indent="0" marL="0">
+                        <a:buNone/>
+                      </a:pPr>
+                      <a:r>
+                        <a:rPr/>
+                        <a:t>10</a:t>
+                      </a:r>
+                    </a:p>
+                  </a:txBody>
+                </a:tc>
+                <a:tc>
+                  <a:txBody>
+                    <a:bodyPr/>
+                    <a:lstStyle/>
+                    <a:p>
+                      <a:pPr lvl="0" indent="0" marL="0">
+                        <a:buNone/>
+                      </a:pPr>
+                      <a:r>
+                        <a:rPr/>
+                        <a:t>UI polish</a:t>
+                      </a:r>
+                    </a:p>
+                  </a:txBody>
+                </a:tc>
+              </a:tr>
+              <a:tr h="0">
+                <a:tc>
+                  <a:txBody>
+                    <a:bodyPr/>
+                    <a:lstStyle/>
+                    <a:p>
+                      <a:pPr lvl="0" indent="0" marL="0">
+                        <a:buNone/>
+                      </a:pPr>
+                      <a:r>
+                        <a:rPr/>
+                        <a:t>11</a:t>
+                      </a:r>
+                    </a:p>
+                  </a:txBody>
+                </a:tc>
+                <a:tc>
+                  <a:txBody>
+                    <a:bodyPr/>
+                    <a:lstStyle/>
+                    <a:p>
+                      <a:pPr lvl="0" indent="0" marL="0">
+                        <a:buNone/>
+                      </a:pPr>
+                      <a:r>
+                        <a:rPr/>
+                        <a:t>Switching to a shared DB</a:t>
+                      </a:r>
+                    </a:p>
+                  </a:txBody>
+                </a:tc>
+              </a:tr>
+            </a:tbl>
+          </a:graphicData>
+        </a:graphic>
+      </p:graphicFrame>
     </p:spTree>
   </p:cSld>
 </p:sld>
@@ -5488,12 +6070,12 @@
       </p:grpSpPr>
       <p:sp>
         <p:nvSpPr>
-          <p:cNvPr id="2" name="Title 1"/>
-          <p:cNvSpPr>
-            <a:spLocks noGrp="1"/>
-          </p:cNvSpPr>
-          <p:nvPr>
-            <p:ph type="title"/>
+          <p:cNvPr id="3" name="Content Placeholder 2"/>
+          <p:cNvSpPr>
+            <a:spLocks noGrp="1"/>
+          </p:cNvSpPr>
+          <p:nvPr>
+            <p:ph idx="1"/>
           </p:nvPr>
         </p:nvSpPr>
         <p:spPr/>
@@ -5506,133 +6088,17 @@
             </a:pPr>
             <a:r>
               <a:rPr/>
-              <a:t>Phase 1 — Project Setup (10 min)</a:t>
-            </a:r>
-          </a:p>
-        </p:txBody>
-      </p:sp>
-      <p:sp>
-        <p:nvSpPr>
-          <p:cNvPr id="3" name="Content Placeholder 2"/>
-          <p:cNvSpPr>
-            <a:spLocks noGrp="1"/>
-          </p:cNvSpPr>
-          <p:nvPr>
-            <p:ph idx="1"/>
-          </p:nvPr>
-        </p:nvSpPr>
-        <p:spPr/>
-        <p:txBody>
-          <a:bodyPr/>
-          <a:lstStyle/>
-          <a:p>
-            <a:pPr lvl="0" indent="0" marL="0">
-              <a:buNone/>
-            </a:pPr>
-            <a:r>
-              <a:rPr/>
-              <a:t>Manual:</a:t>
-            </a:r>
-          </a:p>
-          <a:p>
-            <a:pPr lvl="0"/>
-            <a:r>
-              <a:rPr/>
-              <a:t>Create your project folder + put PDFs in </a:t>
+              <a:t>All documented with full prompts in </a:t>
             </a:r>
             <a:r>
               <a:rPr>
                 <a:latin typeface="Courier"/>
               </a:rPr>
-              <a:t>docs/</a:t>
-            </a:r>
-          </a:p>
-          <a:p>
-            <a:pPr lvl="0"/>
-            <a:r>
-              <a:rPr/>
-              <a:t>Clone the sample: </a:t>
-            </a:r>
-            <a:r>
-              <a:rPr>
-                <a:latin typeface="Courier"/>
-              </a:rPr>
-              <a:t>git clone … cloned</a:t>
-            </a:r>
-          </a:p>
-          <a:p>
-            <a:pPr lvl="0"/>
-            <a:r>
-              <a:rPr>
-                <a:latin typeface="Courier"/>
-              </a:rPr>
-              <a:t>.gitignore</a:t>
-            </a:r>
-            <a:r>
-              <a:rPr/>
-              <a:t> → </a:t>
-            </a:r>
-            <a:r>
-              <a:rPr>
-                <a:latin typeface="Courier"/>
-              </a:rPr>
-              <a:t>cloned/</a:t>
-            </a:r>
-            <a:r>
-              <a:rPr/>
-              <a:t> + </a:t>
-            </a:r>
-            <a:r>
-              <a:rPr>
-                <a:latin typeface="Courier"/>
-              </a:rPr>
-              <a:t>.mcp.json</a:t>
-            </a:r>
-          </a:p>
-          <a:p>
-            <a:pPr lvl="0" indent="0" marL="0">
-              <a:buNone/>
-            </a:pPr>
-            <a:r>
-              <a:rPr/>
-              <a:t>In Claude Code: paste the </a:t>
-            </a:r>
-            <a:r>
-              <a:rPr b="1"/>
-              <a:t>MCP install prompt</a:t>
-            </a:r>
-            <a:r>
-              <a:rPr/>
-              <a:t> (in cheat sheet).</a:t>
-            </a:r>
-          </a:p>
-          <a:p>
-            <a:pPr lvl="0" indent="0" marL="0">
-              <a:buNone/>
-            </a:pPr>
-            <a:r>
-              <a:rPr/>
-              <a:t>Claude installs </a:t>
-            </a:r>
-            <a:r>
-              <a:rPr>
-                <a:latin typeface="Courier"/>
-              </a:rPr>
-              <a:t>uv</a:t>
-            </a:r>
-            <a:r>
-              <a:rPr/>
-              <a:t>, writes </a:t>
-            </a:r>
-            <a:r>
-              <a:rPr>
-                <a:latin typeface="Courier"/>
-              </a:rPr>
-              <a:t>.mcp.json</a:t>
-            </a:r>
-            <a:r>
-              <a:rPr/>
-              <a:t>, restarts itself, verifies the connection to your local SQL Server.</a:t>
+              <a:t>LESSON_STEPS.md</a:t>
+            </a:r>
+            <a:r>
+              <a:rPr/>
+              <a:t>.</a:t>
             </a:r>
           </a:p>
         </p:txBody>
@@ -5679,7 +6145,7 @@
             </a:pPr>
             <a:r>
               <a:rPr/>
-              <a:t>Phase 2 — Extract Analysis to Markdown (20 min)</a:t>
+              <a:t>Three Things Drive This Lesson</a:t>
             </a:r>
           </a:p>
         </p:txBody>
@@ -5703,34 +6169,35 @@
               <a:buNone/>
             </a:pPr>
             <a:r>
-              <a:rPr/>
-              <a:t>Paste </a:t>
-            </a:r>
-            <a:r>
               <a:rPr b="1"/>
-              <a:t>one prompt</a:t>
-            </a:r>
-            <a:r>
-              <a:rPr/>
-              <a:t> — Claude reads both PDFs and produces:</a:t>
-            </a:r>
-          </a:p>
-          <a:p>
-            <a:pPr lvl="0" indent="0">
-              <a:buNone/>
-            </a:pPr>
+              <a:t>Stay in Claude Code.</a:t>
+            </a:r>
+            <a:r>
+              <a:rPr/>
+              <a:t> One tool, no bouncing between SSMS / terminal / browser.</a:t>
+            </a:r>
+          </a:p>
+          <a:p>
+            <a:pPr lvl="0" indent="0" marL="0">
+              <a:buNone/>
+            </a:pPr>
+            <a:r>
+              <a:rPr b="1"/>
+              <a:t>Files are the source of truth.</a:t>
+            </a:r>
+            <a:r>
+              <a:rPr/>
+              <a:t> Markdown + </a:t>
+            </a:r>
             <a:r>
               <a:rPr>
                 <a:latin typeface="Courier"/>
               </a:rPr>
-              <a:t>docs/
-├── org-analysis/01-organization.md
-├── org-analysis/02-interviews.md
-├── org-analysis/03-problems.md
-├── org-analysis/04-business-processes.md
-├── 00-requirements.md
-├── 00e-use-cases.md
-└── design/{class,state,sequence}-diagram.md</a:t>
+              <a:t>.sql</a:t>
+            </a:r>
+            <a:r>
+              <a:rPr/>
+              <a:t> in git. The database is a cached projection.</a:t>
             </a:r>
           </a:p>
           <a:p>
@@ -5739,11 +6206,11 @@
             </a:pPr>
             <a:r>
               <a:rPr b="1"/>
-              <a:t>Then review each file against the PDF.</a:t>
-            </a:r>
-            <a:r>
-              <a:rPr/>
-              <a:t> Counts, tables, wording — Claude drifts here.</a:t>
+              <a:t>Review what Claude produces.</a:t>
+            </a:r>
+            <a:r>
+              <a:rPr/>
+              <a:t> Fast but not careful. Skipping review = silent errors all semester.</a:t>
             </a:r>
           </a:p>
         </p:txBody>
@@ -5790,7 +6257,7 @@
             </a:pPr>
             <a:r>
               <a:rPr/>
-              <a:t>Phase 3 — Generate Your CLAUDE.md (15 min)</a:t>
+              <a:t>Prerequisites (Done Before Class)</a:t>
             </a:r>
           </a:p>
         </p:txBody>
@@ -5815,73 +6282,49 @@
             </a:pPr>
             <a:r>
               <a:rPr/>
-              <a:t>The most important file in your project. Claude reads every doc + the shared </a:t>
-            </a:r>
+              <a:t>In a fresh terminal, all four must succeed:</a:t>
+            </a:r>
+          </a:p>
+          <a:p>
+            <a:pPr lvl="0" indent="0">
+              <a:buNone/>
+            </a:pPr>
             <a:r>
               <a:rPr>
                 <a:latin typeface="Courier"/>
               </a:rPr>
-              <a:t>PATTERNS.md</a:t>
-            </a:r>
-            <a:r>
-              <a:rPr/>
-              <a:t> and produces a self-contained </a:t>
+              <a:t>dotnet --version
+git --version
+uvx --version
+sqlcmd -L</a:t>
+            </a:r>
+          </a:p>
+          <a:p>
+            <a:pPr lvl="0" indent="0" marL="0">
+              <a:buNone/>
+            </a:pPr>
+            <a:r>
+              <a:rPr/>
+              <a:t>Plus: Claude Code signed in, VS 2025 open, SSMS connects.</a:t>
+            </a:r>
+          </a:p>
+          <a:p>
+            <a:pPr lvl="0" indent="0" marL="0">
+              <a:buNone/>
+            </a:pPr>
+            <a:r>
+              <a:rPr/>
+              <a:t>Full details in </a:t>
             </a:r>
             <a:r>
               <a:rPr>
                 <a:latin typeface="Courier"/>
               </a:rPr>
-              <a:t>CLAUDE.md</a:t>
+              <a:t>PREREQS.md</a:t>
             </a:r>
             <a:r>
               <a:rPr/>
               <a:t>.</a:t>
-            </a:r>
-          </a:p>
-          <a:p>
-            <a:pPr lvl="0" indent="0" marL="0">
-              <a:buNone/>
-            </a:pPr>
-            <a:r>
-              <a:rPr/>
-              <a:t>What to verify:</a:t>
-            </a:r>
-          </a:p>
-          <a:p>
-            <a:pPr lvl="0"/>
-            <a:r>
-              <a:rPr/>
-              <a:t>Implementation scope matches what you intend to code</a:t>
-            </a:r>
-          </a:p>
-          <a:p>
-            <a:pPr lvl="0"/>
-            <a:r>
-              <a:rPr/>
-              <a:t>Entity load order is correct (FK targets come before dependents)</a:t>
-            </a:r>
-          </a:p>
-          <a:p>
-            <a:pPr lvl="0"/>
-            <a:r>
-              <a:rPr/>
-              <a:t>Group decisions are real (not invented from the sample)</a:t>
-            </a:r>
-          </a:p>
-          <a:p>
-            <a:pPr lvl="0"/>
-            <a:r>
-              <a:rPr/>
-              <a:t>Counts and lists are accurate</a:t>
-            </a:r>
-          </a:p>
-          <a:p>
-            <a:pPr lvl="0" indent="0" marL="0">
-              <a:buNone/>
-            </a:pPr>
-            <a:r>
-              <a:rPr/>
-              <a:t>Don’t fuss about attribute names — the compiler catches those later.</a:t>
             </a:r>
           </a:p>
         </p:txBody>
@@ -5928,7 +6371,7 @@
             </a:pPr>
             <a:r>
               <a:rPr/>
-              <a:t>Phase 4 — Database Schema + Stored Procedures (25 min)</a:t>
+              <a:t>Phase 1 — Project Setup</a:t>
             </a:r>
           </a:p>
         </p:txBody>
@@ -5948,124 +6391,79 @@
           <a:bodyPr/>
           <a:lstStyle/>
           <a:p>
-            <a:pPr lvl="0" indent="-342900" marL="342900">
-              <a:buAutoNum type="arabicPeriod"/>
-            </a:pPr>
-            <a:r>
-              <a:rPr b="1"/>
-              <a:t>4.0</a:t>
-            </a:r>
-            <a:r>
-              <a:rPr/>
-              <a:t> — Claude creates the project DB via MCP</a:t>
-            </a:r>
-          </a:p>
-          <a:p>
-            <a:pPr lvl="0" indent="-342900" marL="342900">
-              <a:buAutoNum type="arabicPeriod"/>
-            </a:pPr>
-            <a:r>
-              <a:rPr b="1"/>
-              <a:t>4.1</a:t>
-            </a:r>
-            <a:r>
-              <a:rPr/>
-              <a:t> — Generate </a:t>
+            <a:pPr lvl="0" indent="0" marL="0">
+              <a:buNone/>
+            </a:pPr>
+            <a:r>
+              <a:rPr/>
+              <a:t>Manual (~5 min):</a:t>
+            </a:r>
+          </a:p>
+          <a:p>
+            <a:pPr lvl="0"/>
+            <a:r>
+              <a:rPr/>
+              <a:t>Create your project folder</a:t>
+            </a:r>
+          </a:p>
+          <a:p>
+            <a:pPr lvl="0"/>
+            <a:r>
+              <a:rPr/>
+              <a:t>PDFs into </a:t>
             </a:r>
             <a:r>
               <a:rPr>
                 <a:latin typeface="Courier"/>
               </a:rPr>
-              <a:t>scripts/create_database.sql</a:t>
-            </a:r>
-          </a:p>
-          <a:p>
-            <a:pPr lvl="0" indent="-342900" marL="342900">
-              <a:buAutoNum type="arabicPeriod"/>
-            </a:pPr>
-            <a:r>
-              <a:rPr b="1"/>
-              <a:t>4.2</a:t>
-            </a:r>
-            <a:r>
-              <a:rPr/>
-              <a:t> — Review the schema (manual)</a:t>
-            </a:r>
-          </a:p>
-          <a:p>
-            <a:pPr lvl="0" indent="-342900" marL="342900">
-              <a:buAutoNum type="arabicPeriod"/>
-            </a:pPr>
-            <a:r>
-              <a:rPr b="1"/>
-              <a:t>4.3</a:t>
-            </a:r>
-            <a:r>
-              <a:rPr/>
-              <a:t> — Claude runs the schema via MCP</a:t>
-            </a:r>
-          </a:p>
-          <a:p>
-            <a:pPr lvl="0" indent="-342900" marL="342900">
-              <a:buAutoNum type="arabicPeriod"/>
-            </a:pPr>
-            <a:r>
-              <a:rPr b="1"/>
-              <a:t>4.4</a:t>
-            </a:r>
-            <a:r>
-              <a:rPr/>
-              <a:t> — Generate </a:t>
-            </a:r>
+              <a:t>docs/</a:t>
+            </a:r>
+          </a:p>
+          <a:p>
+            <a:pPr lvl="0"/>
             <a:r>
               <a:rPr>
                 <a:latin typeface="Courier"/>
               </a:rPr>
-              <a:t>scripts/stored_procedures.sql</a:t>
-            </a:r>
-            <a:r>
-              <a:rPr/>
-              <a:t> (CRUD only)</a:t>
-            </a:r>
-          </a:p>
-          <a:p>
-            <a:pPr lvl="0" indent="-342900" marL="342900">
-              <a:buAutoNum type="arabicPeriod"/>
-            </a:pPr>
-            <a:r>
-              <a:rPr b="1"/>
-              <a:t>4.5</a:t>
-            </a:r>
-            <a:r>
-              <a:rPr/>
-              <a:t> — Spot-check one entity’s full CRUD cycle</a:t>
-            </a:r>
-          </a:p>
-          <a:p>
-            <a:pPr lvl="0" indent="0" marL="0">
-              <a:buNone/>
-            </a:pPr>
-            <a:r>
-              <a:rPr/>
-              <a:t>PK strategy: </a:t>
-            </a:r>
-            <a:r>
-              <a:rPr b="1"/>
-              <a:t>app-side IDs (no </a:t>
-            </a:r>
-            <a:r>
-              <a:rPr b="1">
+              <a:t>git clone … cloned</a:t>
+            </a:r>
+          </a:p>
+          <a:p>
+            <a:pPr lvl="0"/>
+            <a:r>
+              <a:rPr>
                 <a:latin typeface="Courier"/>
               </a:rPr>
-              <a:t>IDENTITY</a:t>
-            </a:r>
-            <a:r>
-              <a:rPr b="1"/>
-              <a:t>)</a:t>
-            </a:r>
-            <a:r>
-              <a:rPr/>
-              <a:t>. Stored procedures take the PK as a parameter.</a:t>
+              <a:t>.gitignore</a:t>
+            </a:r>
+            <a:r>
+              <a:rPr/>
+              <a:t> → </a:t>
+            </a:r>
+            <a:r>
+              <a:rPr>
+                <a:latin typeface="Courier"/>
+              </a:rPr>
+              <a:t>cloned/</a:t>
+            </a:r>
+            <a:r>
+              <a:rPr/>
+              <a:t> + </a:t>
+            </a:r>
+            <a:r>
+              <a:rPr>
+                <a:latin typeface="Courier"/>
+              </a:rPr>
+              <a:t>.mcp.json</a:t>
+            </a:r>
+          </a:p>
+          <a:p>
+            <a:pPr lvl="0" indent="0" marL="0">
+              <a:buNone/>
+            </a:pPr>
+            <a:r>
+              <a:rPr/>
+              <a:t>Then one Claude prompt installs the MCP, verifies the DB connection.</a:t>
             </a:r>
           </a:p>
         </p:txBody>

</xml_diff>

<commit_message>
Elevate GitHub account from optional to required for groups
Group projects need a shared git remote — the "scripts are source of
truth, sync via git" workflow doesn't work without one, and groups
submit from a shared repo. Every member needs an account to push or be
added as a collaborator (the public sample clone still needs none).

- PREREQS Part C3 rewritten: required, with steps (sign up, create repo +
  add collaborators, set up auth via Claude).
- Added to the bring-to-class checklist.
- Added to the "What You Bring" slide.
- Regenerated docx/pptx.

Co-Authored-By: Claude Opus 4.7 (1M context) <noreply@anthropic.com>
</commit_message>
<xml_diff>
--- a/SLIDE_DECK.pptx
+++ b/SLIDE_DECK.pptx
@@ -5573,6 +5573,13 @@
             <a:r>
               <a:rPr/>
               <a:t>A laptop with all prerequisites installed</a:t>
+            </a:r>
+          </a:p>
+          <a:p>
+            <a:pPr lvl="0"/>
+            <a:r>
+              <a:rPr/>
+              <a:t>A GitHub account (every group member needs one)</a:t>
             </a:r>
           </a:p>
           <a:p>

</xml_diff>